<commit_message>
Update Live Demo Links in README.md
</commit_message>
<xml_diff>
--- a/docs/BudgetBuddy-AI-Presentation.pptx
+++ b/docs/BudgetBuddy-AI-Presentation.pptx
@@ -4,6 +4,9 @@
   <p:sldMasterIdLst>
     <p:sldMasterId id="2147483648" r:id="rId1"/>
   </p:sldMasterIdLst>
+  <p:notesMasterIdLst>
+    <p:notesMasterId r:id="rId16"/>
+  </p:notesMasterIdLst>
   <p:sldIdLst>
     <p:sldId id="256" r:id="rId2"/>
     <p:sldId id="257" r:id="rId3"/>
@@ -14,16 +17,13 @@
     <p:sldId id="262" r:id="rId8"/>
     <p:sldId id="263" r:id="rId9"/>
     <p:sldId id="264" r:id="rId10"/>
-    <p:sldId id="269" r:id="rId20"/>
-    <p:sldId id="265" r:id="rId11"/>
-    <p:sldId id="266" r:id="rId12"/>
-    <p:sldId id="267" r:id="rId13"/>
-    <p:sldId id="268" r:id="rId14"/>
+    <p:sldId id="269" r:id="rId11"/>
+    <p:sldId id="265" r:id="rId12"/>
+    <p:sldId id="266" r:id="rId13"/>
+    <p:sldId id="267" r:id="rId14"/>
+    <p:sldId id="268" r:id="rId15"/>
   </p:sldIdLst>
-  <p:notesMasterIdLst>
-    <p:notesMasterId r:id="rId15"/>
-  </p:notesMasterIdLst>
-  <p:sldSz cx="9144000" cy="5143500"/>
+  <p:sldSz cx="9144000" cy="5143500" type="screen16x9"/>
   <p:notesSz cx="5143500" cy="9144000"/>
   <p:defaultTextStyle>
     <a:lvl1pPr marL="0" algn="l" defTabSz="914400" rtl="0" eaLnBrk="1" latinLnBrk="0" hangingPunct="1">
@@ -117,6 +117,11 @@
       </a:defRPr>
     </a:lvl9pPr>
   </p:defaultTextStyle>
+  <p:extLst>
+    <p:ext uri="{EFAFB233-063F-42B5-8137-9DF3F51BA10A}">
+      <p15:sldGuideLst xmlns:p15="http://schemas.microsoft.com/office/powerpoint/2012/main"/>
+    </p:ext>
+  </p:extLst>
 </p:presentation>
 </file>
 
@@ -142,234 +147,10 @@
           <a:chExt cx="0" cy="0"/>
         </a:xfrm>
       </p:grpSpPr>
-      <p:sp>
-        <p:nvSpPr>
-          <p:cNvPr id="2" name="Header Placeholder 1"/>
-          <p:cNvSpPr>
-            <a:spLocks noGrp="1"/>
-          </p:cNvSpPr>
-          <p:nvPr>
-            <p:ph type="hdr" sz="quarter"/>
-          </p:nvPr>
-        </p:nvSpPr>
-        <p:spPr>
-          <a:xfrm>
-            <a:off x="0" y="0"/>
-            <a:ext cx="2971800" cy="458788"/>
-          </a:xfrm>
-          <a:prstGeom prst="rect">
-            <a:avLst/>
-          </a:prstGeom>
-        </p:spPr>
-        <p:txBody>
-          <a:bodyPr vert="horz" lIns="91440" tIns="45720" rIns="91440" bIns="45720" rtlCol="0"/>
-          <a:lstStyle>
-            <a:lvl1pPr algn="l">
-              <a:defRPr sz="1200"/>
-            </a:lvl1pPr>
-          </a:lstStyle>
-          <a:p>
-            <a:endParaRPr lang="en-US"/>
-          </a:p>
-        </p:txBody>
-      </p:sp>
-      <p:sp>
-        <p:nvSpPr>
-          <p:cNvPr id="3" name="Date Placeholder 2"/>
-          <p:cNvSpPr>
-            <a:spLocks noGrp="1"/>
-          </p:cNvSpPr>
-          <p:nvPr>
-            <p:ph type="dt" idx="1"/>
-          </p:nvPr>
-        </p:nvSpPr>
-        <p:spPr>
-          <a:xfrm>
-            <a:off x="3884613" y="0"/>
-            <a:ext cx="2971800" cy="458788"/>
-          </a:xfrm>
-          <a:prstGeom prst="rect">
-            <a:avLst/>
-          </a:prstGeom>
-        </p:spPr>
-        <p:txBody>
-          <a:bodyPr vert="horz" lIns="91440" tIns="45720" rIns="91440" bIns="45720" rtlCol="0"/>
-          <a:lstStyle>
-            <a:lvl1pPr algn="r">
-              <a:defRPr sz="1200"/>
-            </a:lvl1pPr>
-          </a:lstStyle>
-          <a:p>
-            <a:fld id="{5282F153-3F37-0F45-9E97-73ACFA13230C}" type="datetimeFigureOut">
-              <a:rPr lang="en-US"/>
-              <a:t>7/23/19</a:t>
-            </a:fld>
-            <a:endParaRPr lang="en-US"/>
-          </a:p>
-        </p:txBody>
-      </p:sp>
-      <p:sp>
-        <p:nvSpPr>
-          <p:cNvPr id="4" name="Slide Image Placeholder 3"/>
-          <p:cNvSpPr>
-            <a:spLocks noGrp="1" noRot="1" noChangeAspect="1"/>
-          </p:cNvSpPr>
-          <p:nvPr>
-            <p:ph type="sldImg" idx="2"/>
-          </p:nvPr>
-        </p:nvSpPr>
-        <p:spPr>
-          <a:xfrm>
-            <a:off x="685800" y="1143000"/>
-            <a:ext cx="5486400" cy="3086100"/>
-          </a:xfrm>
-          <a:prstGeom prst="rect">
-            <a:avLst/>
-          </a:prstGeom>
-          <a:noFill/>
-          <a:ln w="12700">
-            <a:solidFill>
-              <a:prstClr val="black"/>
-            </a:solidFill>
-          </a:ln>
-        </p:spPr>
-        <p:txBody>
-          <a:bodyPr vert="horz" lIns="91440" tIns="45720" rIns="91440" bIns="45720" rtlCol="0" anchor="ctr"/>
-          <a:lstStyle/>
-          <a:p>
-            <a:endParaRPr lang="en-US"/>
-          </a:p>
-        </p:txBody>
-      </p:sp>
-      <p:sp>
-        <p:nvSpPr>
-          <p:cNvPr id="5" name="Notes Placeholder 4"/>
-          <p:cNvSpPr>
-            <a:spLocks noGrp="1"/>
-          </p:cNvSpPr>
-          <p:nvPr>
-            <p:ph type="body" sz="quarter" idx="3"/>
-          </p:nvPr>
-        </p:nvSpPr>
-        <p:spPr>
-          <a:xfrm>
-            <a:off x="685800" y="4400550"/>
-            <a:ext cx="5486400" cy="3600450"/>
-          </a:xfrm>
-          <a:prstGeom prst="rect">
-            <a:avLst/>
-          </a:prstGeom>
-        </p:spPr>
-        <p:txBody>
-          <a:bodyPr vert="horz" lIns="91440" tIns="45720" rIns="91440" bIns="45720" rtlCol="0"/>
-          <a:lstStyle/>
-          <a:p>
-            <a:pPr lvl="0"/>
-            <a:r>
-              <a:rPr lang="en-US"/>
-              <a:t>Click to edit Master text styles</a:t>
-            </a:r>
-          </a:p>
-          <a:p>
-            <a:pPr lvl="1"/>
-            <a:r>
-              <a:rPr lang="en-US"/>
-              <a:t>Second level</a:t>
-            </a:r>
-          </a:p>
-          <a:p>
-            <a:pPr lvl="2"/>
-            <a:r>
-              <a:rPr lang="en-US"/>
-              <a:t>Third level</a:t>
-            </a:r>
-          </a:p>
-          <a:p>
-            <a:pPr lvl="3"/>
-            <a:r>
-              <a:rPr lang="en-US"/>
-              <a:t>Fourth level</a:t>
-            </a:r>
-          </a:p>
-          <a:p>
-            <a:pPr lvl="4"/>
-            <a:r>
-              <a:rPr lang="en-US"/>
-              <a:t>Fifth level</a:t>
-            </a:r>
-          </a:p>
-        </p:txBody>
-      </p:sp>
-      <p:sp>
-        <p:nvSpPr>
-          <p:cNvPr id="6" name="Footer Placeholder 5"/>
-          <p:cNvSpPr>
-            <a:spLocks noGrp="1"/>
-          </p:cNvSpPr>
-          <p:nvPr>
-            <p:ph type="ftr" sz="quarter" idx="4"/>
-          </p:nvPr>
-        </p:nvSpPr>
-        <p:spPr>
-          <a:xfrm>
-            <a:off x="0" y="8685213"/>
-            <a:ext cx="2971800" cy="458787"/>
-          </a:xfrm>
-          <a:prstGeom prst="rect">
-            <a:avLst/>
-          </a:prstGeom>
-        </p:spPr>
-        <p:txBody>
-          <a:bodyPr vert="horz" lIns="91440" tIns="45720" rIns="91440" bIns="45720" rtlCol="0" anchor="b"/>
-          <a:lstStyle>
-            <a:lvl1pPr algn="l">
-              <a:defRPr sz="1200"/>
-            </a:lvl1pPr>
-          </a:lstStyle>
-          <a:p>
-            <a:endParaRPr lang="en-US"/>
-          </a:p>
-        </p:txBody>
-      </p:sp>
-      <p:sp>
-        <p:nvSpPr>
-          <p:cNvPr id="7" name="Slide Number Placeholder 6"/>
-          <p:cNvSpPr>
-            <a:spLocks noGrp="1"/>
-          </p:cNvSpPr>
-          <p:nvPr>
-            <p:ph type="sldNum" sz="quarter" idx="5"/>
-          </p:nvPr>
-        </p:nvSpPr>
-        <p:spPr>
-          <a:xfrm>
-            <a:off x="3884613" y="8685213"/>
-            <a:ext cx="2971800" cy="458787"/>
-          </a:xfrm>
-          <a:prstGeom prst="rect">
-            <a:avLst/>
-          </a:prstGeom>
-        </p:spPr>
-        <p:txBody>
-          <a:bodyPr vert="horz" lIns="91440" tIns="45720" rIns="91440" bIns="45720" rtlCol="0" anchor="b"/>
-          <a:lstStyle>
-            <a:lvl1pPr algn="r">
-              <a:defRPr sz="1200"/>
-            </a:lvl1pPr>
-          </a:lstStyle>
-          <a:p>
-            <a:fld id="{CE5E9CC1-C706-0F49-92D6-E571CC5EEA8F}" type="slidenum">
-              <a:rPr lang="en-US"/>
-              <a:t>‹#›</a:t>
-            </a:fld>
-            <a:endParaRPr lang="en-US"/>
-          </a:p>
-        </p:txBody>
-      </p:sp>
     </p:spTree>
     <p:extLst>
       <p:ext uri="{BB962C8B-B14F-4D97-AF65-F5344CB8AC3E}">
-        <p14:creationId xmlns:p14="http://schemas.microsoft.com/office/powerpoint/2010/main" val="1024086991"/>
+        <p14:creationId xmlns:p14="http://schemas.microsoft.com/office/powerpoint/2010/main" val="2010350174"/>
       </p:ext>
     </p:extLst>
   </p:cSld>
@@ -517,7 +298,6 @@
               <a:rPr lang="en-US" dirty="0"/>
               <a:t>Introduce yourself and the project: a personal expense tracker where users can type or paste what they spent and ask questions about their own spending. Mention the three pieces: Firebase for sign-in and data, a Python FastAPI backend, and Groq for the AI.</a:t>
             </a:r>
-            <a:endParaRPr lang="en-US" dirty="0"/>
           </a:p>
         </p:txBody>
       </p:sp>
@@ -603,9 +383,8 @@
           <a:p>
             <a:r>
               <a:rPr lang="en-US" dirty="0"/>
-              <a:t>The backend is one file. Tests replace Groq with a mock transport and Firebase verification with a stub, so they run in a fraction of a second without network access.</a:t>
-            </a:r>
-            <a:endParaRPr lang="en-US" dirty="0"/>
+              <a:t>Every user can create their own categories. Open the Category dropdown and choose New category, or use Manage categories on the dashboard. Categories have a name and a colour, are stored on the user document as customCats, and show up in charts, limits, filters, reports and the AI prompts. Deleting one moves its expenses to Other. A jsdom test with 29 checks covers this feature.</a:t>
+            </a:r>
           </a:p>
         </p:txBody>
       </p:sp>
@@ -691,9 +470,8 @@
           <a:p>
             <a:r>
               <a:rPr lang="en-US" dirty="0"/>
-              <a:t>Deploy Vercel first so you have a backend URL. Remember to add the Vercel domain and later the Firebase Hosting domain to Firebase Authentication authorized domains and to ALLOWED_ORIGINS, then redeploy after changing variables.</a:t>
-            </a:r>
-            <a:endParaRPr lang="en-US" dirty="0"/>
+              <a:t>The backend is one file. Tests replace Groq with a mock transport and Firebase verification with a stub, so they run in a fraction of a second without network access.</a:t>
+            </a:r>
           </a:p>
         </p:txBody>
       </p:sp>
@@ -779,9 +557,8 @@
           <a:p>
             <a:r>
               <a:rPr lang="en-US" dirty="0"/>
-              <a:t>Be upfront about limits. The most important one is the in-memory rate limiter, which is fine for a student project but would move to Redis or Firestore in production.</a:t>
-            </a:r>
-            <a:endParaRPr lang="en-US" dirty="0"/>
+              <a:t>Deploy Vercel first so you have a backend URL. Remember to add the Vercel domain and later the Firebase Hosting domain to Firebase Authentication authorized domains and to ALLOWED_ORIGINS, then redeploy after changing variables.</a:t>
+            </a:r>
           </a:p>
         </p:txBody>
       </p:sp>
@@ -867,9 +644,8 @@
           <a:p>
             <a:r>
               <a:rPr lang="en-US" dirty="0"/>
-              <a:t>Replace the three link placeholders with your real addresses after deployment. Offer a live demo: sign in, add an expense, use quick add and ask a question.</a:t>
-            </a:r>
-            <a:endParaRPr lang="en-US" dirty="0"/>
+              <a:t>Be upfront about limits. The most important one is the in-memory rate limiter, which is fine for a student project but would move to Redis or Firestore in production.</a:t>
+            </a:r>
           </a:p>
         </p:txBody>
       </p:sp>
@@ -955,9 +731,8 @@
           <a:p>
             <a:r>
               <a:rPr lang="en-US" dirty="0"/>
-              <a:t>Every user can create their own categories. Open the Category dropdown and choose New category, or use Manage categories on the dashboard. Categories have a name and a colour, are stored on the user document as customCats, and show up in charts, limits, filters, reports and the AI prompts. Deleting one moves its expenses to Other. A jsdom test with 29 checks covers this feature.</a:t>
-            </a:r>
-            <a:endParaRPr lang="en-US" dirty="0"/>
+              <a:t>Replace the three link placeholders with your real addresses after deployment. Offer a live demo: sign in, add an expense, use quick add and ask a question.</a:t>
+            </a:r>
           </a:p>
         </p:txBody>
       </p:sp>
@@ -978,7 +753,7 @@
           <a:p>
             <a:fld id="{F7021451-1387-4CA6-816F-3879F97B5CBC}" type="slidenum">
               <a:rPr lang="en-US"/>
-              <a:t>10</a:t>
+              <a:t>14</a:t>
             </a:fld>
             <a:endParaRPr lang="en-US"/>
           </a:p>
@@ -1045,7 +820,6 @@
               <a:rPr lang="en-US" dirty="0"/>
               <a:t>Explain the problem: people stop tracking because it is slow. Local payment methods and languages are rarely supported. We also wanted a safe design where the API key is never exposed.</a:t>
             </a:r>
-            <a:endParaRPr lang="en-US" dirty="0"/>
           </a:p>
         </p:txBody>
       </p:sp>
@@ -1133,7 +907,6 @@
               <a:rPr lang="en-US" dirty="0"/>
               <a:t>Walk through the six groups. The first row is the core assignment plus AI. The second row is extra: budgets, wallets, recurring bills, splitting, offline use and Urdu.</a:t>
             </a:r>
-            <a:endParaRPr lang="en-US" dirty="0"/>
           </a:p>
         </p:txBody>
       </p:sp>
@@ -1221,7 +994,6 @@
               <a:rPr lang="en-US" dirty="0"/>
               <a:t>Read through the table quickly. Every requirement from the assignment is implemented; everything else in the project is extra. The form also lets users create their own categories on top of the five required ones.</a:t>
             </a:r>
-            <a:endParaRPr lang="en-US" dirty="0"/>
           </a:p>
         </p:txBody>
       </p:sp>
@@ -1309,7 +1081,6 @@
               <a:rPr lang="en-US" dirty="0"/>
               <a:t>Three parts. The frontend talks to Firebase directly for sign-in and data. For AI features it talks to our own FastAPI backend, which holds the Groq key.</a:t>
             </a:r>
-            <a:endParaRPr lang="en-US" dirty="0"/>
           </a:p>
         </p:txBody>
       </p:sp>
@@ -1397,7 +1168,6 @@
               <a:rPr lang="en-US" dirty="0"/>
               <a:t>Walk the sequence left to right. The browser never sees the Groq key. The backend verifies the Firebase token, validates the body, applies the rate limit and only then calls Groq.</a:t>
             </a:r>
-            <a:endParaRPr lang="en-US" dirty="0"/>
           </a:p>
         </p:txBody>
       </p:sp>
@@ -1485,7 +1255,6 @@
               <a:rPr lang="en-US" dirty="0"/>
               <a:t>No frontend framework or build step. The backend is a single small Python file. Firebase handles identity and data; Groq provides fast LLM inference.</a:t>
             </a:r>
-            <a:endParaRPr lang="en-US" dirty="0"/>
           </a:p>
         </p:txBody>
       </p:sp>
@@ -1573,7 +1342,6 @@
               <a:rPr lang="en-US" dirty="0"/>
               <a:t>All records live under users/{uid}. One security rule means a user can only read and write their own documents. Firestore also keeps an offline cache so the app works without internet. Custom categories are stored on the same user document as a customCats list, so the same rule protects them.</a:t>
             </a:r>
-            <a:endParaRPr lang="en-US" dirty="0"/>
           </a:p>
         </p:txBody>
       </p:sp>
@@ -1661,7 +1429,6 @@
               <a:rPr lang="en-US" dirty="0"/>
               <a:t>Four AI capabilities share one client function. Prompts use JSON mode where structured output is needed, are told to use only the supplied data and to ignore instructions hidden in expense titles. The AI never saves anything by itself.</a:t>
             </a:r>
-            <a:endParaRPr lang="en-US" dirty="0"/>
           </a:p>
         </p:txBody>
       </p:sp>
@@ -1739,6 +1506,7 @@
         <a:solidFill>
           <a:schemeClr val="tx2"/>
         </a:solidFill>
+        <a:effectLst/>
       </p:bgPr>
     </p:bg>
     <p:spTree>
@@ -1771,6 +1539,7 @@
         <a:solidFill>
           <a:schemeClr val="bg1"/>
         </a:solidFill>
+        <a:effectLst/>
       </p:bgPr>
     </p:bg>
     <p:spTree>
@@ -1808,7 +1577,7 @@
           <a:bodyPr wrap="square" lIns="0" tIns="0" rIns="0" bIns="0" rtlCol="0" anchor="ctr"/>
           <a:lstStyle/>
           <a:p>
-            <a:pPr indent="0" marL="0">
+            <a:pPr marL="0" indent="0">
               <a:buNone/>
             </a:pPr>
             <a:r>
@@ -1843,7 +1612,7 @@
           </a:prstGeom>
           <a:extLst>
             <a:ext uri="{C572A759-6A51-4108-AA02-DFA0A04FC94B}">
-              <ma14:wrappingTextBoxFlag xmlns:ma14="http://schemas.microsoft.com/office/mac/drawingml/2011/main" val="0"/>
+              <ma14:wrappingTextBoxFlag xmlns="" xmlns:ma14="http://schemas.microsoft.com/office/mac/drawingml/2011/main" val="0"/>
             </a:ext>
           </a:extLst>
         </p:spPr>
@@ -1861,8 +1630,8 @@
           <a:p>
             <a:pPr algn="r"/>
             <a:fld id="{F7021451-1387-4CA6-816F-3879F97B5CBC}" type="slidenum">
-              <a:rPr b="0" lang="en-US"/>
-              <a:t>1003</a:t>
+              <a:rPr lang="en-US" b="0"/>
+              <a:t>‹#›</a:t>
             </a:fld>
             <a:endParaRPr lang="en-US"/>
           </a:p>
@@ -1879,6 +1648,11 @@
 <file path=ppt/slideMasters/slideMaster1.xml><?xml version="1.0" encoding="utf-8"?>
 <p:sldMaster xmlns:a="http://schemas.openxmlformats.org/drawingml/2006/main" xmlns:r="http://schemas.openxmlformats.org/officeDocument/2006/relationships" xmlns:p="http://schemas.openxmlformats.org/presentationml/2006/main">
   <p:cSld>
+    <p:bg>
+      <p:bgRef idx="1001">
+        <a:schemeClr val="bg1"/>
+      </p:bgRef>
+    </p:bg>
     <p:spTree>
       <p:nvGrpSpPr>
         <p:cNvPr id="1" name=""/>
@@ -1913,7 +1687,7 @@
           </a:prstGeom>
           <a:extLst>
             <a:ext uri="{C572A759-6A51-4108-AA02-DFA0A04FC94B}">
-              <ma14:wrappingTextBoxFlag xmlns:ma14="http://schemas.microsoft.com/office/mac/drawingml/2011/main" val="0"/>
+              <ma14:wrappingTextBoxFlag xmlns="" xmlns:ma14="http://schemas.microsoft.com/office/mac/drawingml/2011/main" val="0"/>
             </a:ext>
           </a:extLst>
         </p:spPr>
@@ -1931,8 +1705,8 @@
           <a:p>
             <a:pPr algn="r"/>
             <a:fld id="{F7021451-1387-4CA6-816F-3879F97B5CBC}" type="slidenum">
-              <a:rPr b="0" lang="en-US"/>
-              <a:t>null</a:t>
+              <a:rPr lang="en-US" b="0"/>
+              <a:t>‹#›</a:t>
             </a:fld>
             <a:endParaRPr lang="en-US"/>
           </a:p>
@@ -2292,11 +2066,11 @@
           <a:bodyPr wrap="square" lIns="0" tIns="0" rIns="0" bIns="0" rtlCol="0" anchor="ctr"/>
           <a:lstStyle/>
           <a:p>
-            <a:pPr indent="0" marL="0">
+            <a:pPr marL="0" indent="0">
               <a:buNone/>
             </a:pPr>
             <a:r>
-              <a:rPr lang="en-US" sz="1300" b="1" spc="400" kern="0" dirty="0">
+              <a:rPr lang="en-US" sz="1300" b="1" kern="0" spc="400" dirty="0">
                 <a:solidFill>
                   <a:schemeClr val="accent2"/>
                 </a:solidFill>
@@ -2328,7 +2102,7 @@
           <a:bodyPr wrap="square" lIns="0" tIns="0" rIns="0" bIns="0" rtlCol="0" anchor="ctr"/>
           <a:lstStyle/>
           <a:p>
-            <a:pPr indent="0" marL="0">
+            <a:pPr marL="0" indent="0">
               <a:buNone/>
             </a:pPr>
             <a:r>
@@ -2367,7 +2141,7 @@
           <a:bodyPr wrap="square" lIns="0" tIns="0" rIns="0" bIns="0" rtlCol="0" anchor="ctr"/>
           <a:lstStyle/>
           <a:p>
-            <a:pPr indent="0" marL="0">
+            <a:pPr marL="0" indent="0">
               <a:buNone/>
             </a:pPr>
             <a:r>
@@ -2403,7 +2177,7 @@
           <a:bodyPr wrap="square" lIns="0" tIns="0" rIns="0" bIns="0" rtlCol="0" anchor="ctr"/>
           <a:lstStyle/>
           <a:p>
-            <a:pPr indent="0" marL="0">
+            <a:pPr marL="0" indent="0">
               <a:buNone/>
             </a:pPr>
             <a:r>
@@ -2417,7 +2191,7 @@
             <a:endParaRPr lang="en-US" sz="1500" dirty="0"/>
           </a:p>
           <a:p>
-            <a:pPr indent="0" marL="0">
+            <a:pPr marL="0" indent="0">
               <a:buNone/>
             </a:pPr>
             <a:r>
@@ -2441,6 +2215,867 @@
 </file>
 
 <file path=ppt/slides/slide10.xml><?xml version="1.0" encoding="utf-8"?>
+<p:sld xmlns:a="http://schemas.openxmlformats.org/drawingml/2006/main" xmlns:r="http://schemas.openxmlformats.org/officeDocument/2006/relationships" xmlns:p="http://schemas.openxmlformats.org/presentationml/2006/main">
+  <p:cSld name="Slide 9">
+    <p:spTree>
+      <p:nvGrpSpPr>
+        <p:cNvPr id="1" name=""/>
+        <p:cNvGrpSpPr/>
+        <p:nvPr/>
+      </p:nvGrpSpPr>
+      <p:grpSpPr>
+        <a:xfrm>
+          <a:off x="0" y="0"/>
+          <a:ext cx="0" cy="0"/>
+          <a:chOff x="0" y="0"/>
+          <a:chExt cx="0" cy="0"/>
+        </a:xfrm>
+      </p:grpSpPr>
+      <p:sp>
+        <p:nvSpPr>
+          <p:cNvPr id="2" name="Title"/>
+          <p:cNvSpPr txBox="1"/>
+          <p:nvPr/>
+        </p:nvSpPr>
+        <p:spPr>
+          <a:xfrm>
+            <a:off x="457200" y="274320"/>
+            <a:ext cx="8229600" cy="685800"/>
+          </a:xfrm>
+          <a:prstGeom prst="rect">
+            <a:avLst/>
+          </a:prstGeom>
+          <a:noFill/>
+          <a:ln/>
+        </p:spPr>
+        <p:txBody>
+          <a:bodyPr wrap="square" lIns="0" tIns="0" rIns="0" bIns="0" rtlCol="0" anchor="ctr"/>
+          <a:lstStyle/>
+          <a:p>
+            <a:pPr marL="0" indent="0">
+              <a:buNone/>
+            </a:pPr>
+            <a:r>
+              <a:rPr lang="en-US" sz="3000" b="1" dirty="0">
+                <a:solidFill>
+                  <a:schemeClr val="tx2"/>
+                </a:solidFill>
+                <a:latin typeface="Cambria" pitchFamily="34" charset="0"/>
+                <a:ea typeface="Cambria" pitchFamily="34" charset="-122"/>
+                <a:cs typeface="Cambria" pitchFamily="34" charset="-120"/>
+              </a:rPr>
+              <a:t>Custom categories</a:t>
+            </a:r>
+            <a:endParaRPr lang="en-US" sz="3000" dirty="0"/>
+          </a:p>
+        </p:txBody>
+      </p:sp>
+      <p:sp>
+        <p:nvSpPr>
+          <p:cNvPr id="3" name="Category row 1"/>
+          <p:cNvSpPr/>
+          <p:nvPr/>
+        </p:nvSpPr>
+        <p:spPr>
+          <a:xfrm>
+            <a:off x="457200" y="1188720"/>
+            <a:ext cx="4754880" cy="749808"/>
+          </a:xfrm>
+          <a:prstGeom prst="roundRect">
+            <a:avLst>
+              <a:gd name="adj" fmla="val 14634"/>
+            </a:avLst>
+          </a:prstGeom>
+          <a:solidFill>
+            <a:schemeClr val="bg2"/>
+          </a:solidFill>
+          <a:ln w="12700">
+            <a:solidFill>
+              <a:schemeClr val="bg2"/>
+            </a:solidFill>
+            <a:prstDash val="solid"/>
+          </a:ln>
+        </p:spPr>
+      </p:sp>
+      <p:sp>
+        <p:nvSpPr>
+          <p:cNvPr id="4" name="Category icon 1 circle"/>
+          <p:cNvSpPr/>
+          <p:nvPr/>
+        </p:nvSpPr>
+        <p:spPr>
+          <a:xfrm>
+            <a:off x="594360" y="1316736"/>
+            <a:ext cx="493776" cy="493776"/>
+          </a:xfrm>
+          <a:prstGeom prst="ellipse">
+            <a:avLst/>
+          </a:prstGeom>
+          <a:solidFill>
+            <a:schemeClr val="accent1"/>
+          </a:solidFill>
+          <a:ln w="12700">
+            <a:solidFill>
+              <a:schemeClr val="accent1"/>
+            </a:solidFill>
+            <a:prstDash val="solid"/>
+          </a:ln>
+        </p:spPr>
+      </p:sp>
+      <p:pic>
+        <p:nvPicPr>
+          <p:cNvPr id="5" name="Category icon 1 icon" descr="AI icon 1"/>
+          <p:cNvPicPr>
+            <a:picLocks noChangeAspect="1"/>
+          </p:cNvPicPr>
+          <p:nvPr/>
+        </p:nvPicPr>
+        <p:blipFill>
+          <a:blip r:embed="rId3"/>
+          <a:stretch>
+            <a:fillRect/>
+          </a:stretch>
+        </p:blipFill>
+        <p:spPr>
+          <a:xfrm>
+            <a:off x="722742" y="1445118"/>
+            <a:ext cx="237012" cy="237012"/>
+          </a:xfrm>
+          <a:prstGeom prst="rect">
+            <a:avLst/>
+          </a:prstGeom>
+        </p:spPr>
+      </p:pic>
+      <p:sp>
+        <p:nvSpPr>
+          <p:cNvPr id="6" name="Category head 1"/>
+          <p:cNvSpPr txBox="1"/>
+          <p:nvPr/>
+        </p:nvSpPr>
+        <p:spPr>
+          <a:xfrm>
+            <a:off x="1280160" y="1261872"/>
+            <a:ext cx="3840480" cy="274320"/>
+          </a:xfrm>
+          <a:prstGeom prst="rect">
+            <a:avLst/>
+          </a:prstGeom>
+          <a:noFill/>
+          <a:ln/>
+        </p:spPr>
+        <p:txBody>
+          <a:bodyPr wrap="square" lIns="0" tIns="0" rIns="0" bIns="0" rtlCol="0" anchor="ctr"/>
+          <a:lstStyle/>
+          <a:p>
+            <a:pPr marL="0" indent="0">
+              <a:buNone/>
+            </a:pPr>
+            <a:r>
+              <a:rPr lang="en-US" sz="1400" b="1" dirty="0">
+                <a:solidFill>
+                  <a:schemeClr val="tx2"/>
+                </a:solidFill>
+              </a:rPr>
+              <a:t>Create anywhere</a:t>
+            </a:r>
+            <a:endParaRPr lang="en-US" sz="1400" dirty="0"/>
+          </a:p>
+        </p:txBody>
+      </p:sp>
+      <p:sp>
+        <p:nvSpPr>
+          <p:cNvPr id="7" name="Category text 1"/>
+          <p:cNvSpPr txBox="1"/>
+          <p:nvPr/>
+        </p:nvSpPr>
+        <p:spPr>
+          <a:xfrm>
+            <a:off x="1280160" y="1554480"/>
+            <a:ext cx="3840480" cy="320040"/>
+          </a:xfrm>
+          <a:prstGeom prst="rect">
+            <a:avLst/>
+          </a:prstGeom>
+          <a:noFill/>
+          <a:ln/>
+        </p:spPr>
+        <p:txBody>
+          <a:bodyPr wrap="square" lIns="0" tIns="0" rIns="0" bIns="0" rtlCol="0" anchor="t"/>
+          <a:lstStyle/>
+          <a:p>
+            <a:pPr marL="0" indent="0">
+              <a:buNone/>
+            </a:pPr>
+            <a:r>
+              <a:rPr lang="en-US" sz="1200" dirty="0">
+                <a:solidFill>
+                  <a:schemeClr val="tx1"/>
+                </a:solidFill>
+              </a:rPr>
+              <a:t>New category… in any form, or Manage categories</a:t>
+            </a:r>
+            <a:endParaRPr lang="en-US" sz="1200" dirty="0"/>
+          </a:p>
+        </p:txBody>
+      </p:sp>
+      <p:sp>
+        <p:nvSpPr>
+          <p:cNvPr id="8" name="Category row 2"/>
+          <p:cNvSpPr/>
+          <p:nvPr/>
+        </p:nvSpPr>
+        <p:spPr>
+          <a:xfrm>
+            <a:off x="457200" y="2057400"/>
+            <a:ext cx="4754880" cy="749808"/>
+          </a:xfrm>
+          <a:prstGeom prst="roundRect">
+            <a:avLst>
+              <a:gd name="adj" fmla="val 14634"/>
+            </a:avLst>
+          </a:prstGeom>
+          <a:solidFill>
+            <a:schemeClr val="bg2"/>
+          </a:solidFill>
+          <a:ln w="12700">
+            <a:solidFill>
+              <a:schemeClr val="bg2"/>
+            </a:solidFill>
+            <a:prstDash val="solid"/>
+          </a:ln>
+        </p:spPr>
+      </p:sp>
+      <p:sp>
+        <p:nvSpPr>
+          <p:cNvPr id="9" name="Category icon 2 circle"/>
+          <p:cNvSpPr/>
+          <p:nvPr/>
+        </p:nvSpPr>
+        <p:spPr>
+          <a:xfrm>
+            <a:off x="594360" y="2185416"/>
+            <a:ext cx="493776" cy="493776"/>
+          </a:xfrm>
+          <a:prstGeom prst="ellipse">
+            <a:avLst/>
+          </a:prstGeom>
+          <a:solidFill>
+            <a:schemeClr val="accent1"/>
+          </a:solidFill>
+          <a:ln w="12700">
+            <a:solidFill>
+              <a:schemeClr val="accent1"/>
+            </a:solidFill>
+            <a:prstDash val="solid"/>
+          </a:ln>
+        </p:spPr>
+      </p:sp>
+      <p:pic>
+        <p:nvPicPr>
+          <p:cNvPr id="10" name="Category icon 2 icon" descr="AI icon 2"/>
+          <p:cNvPicPr>
+            <a:picLocks noChangeAspect="1"/>
+          </p:cNvPicPr>
+          <p:nvPr/>
+        </p:nvPicPr>
+        <p:blipFill>
+          <a:blip r:embed="rId4"/>
+          <a:stretch>
+            <a:fillRect/>
+          </a:stretch>
+        </p:blipFill>
+        <p:spPr>
+          <a:xfrm>
+            <a:off x="722742" y="2313798"/>
+            <a:ext cx="237012" cy="237012"/>
+          </a:xfrm>
+          <a:prstGeom prst="rect">
+            <a:avLst/>
+          </a:prstGeom>
+        </p:spPr>
+      </p:pic>
+      <p:sp>
+        <p:nvSpPr>
+          <p:cNvPr id="11" name="Category head 2"/>
+          <p:cNvSpPr txBox="1"/>
+          <p:nvPr/>
+        </p:nvSpPr>
+        <p:spPr>
+          <a:xfrm>
+            <a:off x="1280160" y="2130552"/>
+            <a:ext cx="3840480" cy="274320"/>
+          </a:xfrm>
+          <a:prstGeom prst="rect">
+            <a:avLst/>
+          </a:prstGeom>
+          <a:noFill/>
+          <a:ln/>
+        </p:spPr>
+        <p:txBody>
+          <a:bodyPr wrap="square" lIns="0" tIns="0" rIns="0" bIns="0" rtlCol="0" anchor="ctr"/>
+          <a:lstStyle/>
+          <a:p>
+            <a:pPr marL="0" indent="0">
+              <a:buNone/>
+            </a:pPr>
+            <a:r>
+              <a:rPr lang="en-US" sz="1400" b="1" dirty="0">
+                <a:solidFill>
+                  <a:schemeClr val="tx2"/>
+                </a:solidFill>
+              </a:rPr>
+              <a:t>Name and colour</a:t>
+            </a:r>
+            <a:endParaRPr lang="en-US" sz="1400" dirty="0"/>
+          </a:p>
+        </p:txBody>
+      </p:sp>
+      <p:sp>
+        <p:nvSpPr>
+          <p:cNvPr id="12" name="Category text 2"/>
+          <p:cNvSpPr txBox="1"/>
+          <p:nvPr/>
+        </p:nvSpPr>
+        <p:spPr>
+          <a:xfrm>
+            <a:off x="1280160" y="2423160"/>
+            <a:ext cx="3840480" cy="320040"/>
+          </a:xfrm>
+          <a:prstGeom prst="rect">
+            <a:avLst/>
+          </a:prstGeom>
+          <a:noFill/>
+          <a:ln/>
+        </p:spPr>
+        <p:txBody>
+          <a:bodyPr wrap="square" lIns="0" tIns="0" rIns="0" bIns="0" rtlCol="0" anchor="t"/>
+          <a:lstStyle/>
+          <a:p>
+            <a:pPr marL="0" indent="0">
+              <a:buNone/>
+            </a:pPr>
+            <a:r>
+              <a:rPr lang="en-US" sz="1200" dirty="0">
+                <a:solidFill>
+                  <a:schemeClr val="tx1"/>
+                </a:solidFill>
+              </a:rPr>
+              <a:t>Up to 24 characters, 20 per user, no duplicates</a:t>
+            </a:r>
+            <a:endParaRPr lang="en-US" sz="1200" dirty="0"/>
+          </a:p>
+        </p:txBody>
+      </p:sp>
+      <p:sp>
+        <p:nvSpPr>
+          <p:cNvPr id="13" name="Category row 3"/>
+          <p:cNvSpPr/>
+          <p:nvPr/>
+        </p:nvSpPr>
+        <p:spPr>
+          <a:xfrm>
+            <a:off x="457200" y="2926080"/>
+            <a:ext cx="4754880" cy="749808"/>
+          </a:xfrm>
+          <a:prstGeom prst="roundRect">
+            <a:avLst>
+              <a:gd name="adj" fmla="val 14634"/>
+            </a:avLst>
+          </a:prstGeom>
+          <a:solidFill>
+            <a:schemeClr val="bg2"/>
+          </a:solidFill>
+          <a:ln w="12700">
+            <a:solidFill>
+              <a:schemeClr val="bg2"/>
+            </a:solidFill>
+            <a:prstDash val="solid"/>
+          </a:ln>
+        </p:spPr>
+      </p:sp>
+      <p:sp>
+        <p:nvSpPr>
+          <p:cNvPr id="14" name="Category icon 3 circle"/>
+          <p:cNvSpPr/>
+          <p:nvPr/>
+        </p:nvSpPr>
+        <p:spPr>
+          <a:xfrm>
+            <a:off x="594360" y="3054096"/>
+            <a:ext cx="493776" cy="493776"/>
+          </a:xfrm>
+          <a:prstGeom prst="ellipse">
+            <a:avLst/>
+          </a:prstGeom>
+          <a:solidFill>
+            <a:schemeClr val="accent1"/>
+          </a:solidFill>
+          <a:ln w="12700">
+            <a:solidFill>
+              <a:schemeClr val="accent1"/>
+            </a:solidFill>
+            <a:prstDash val="solid"/>
+          </a:ln>
+        </p:spPr>
+      </p:sp>
+      <p:pic>
+        <p:nvPicPr>
+          <p:cNvPr id="15" name="Category icon 3 icon" descr="AI icon 3"/>
+          <p:cNvPicPr>
+            <a:picLocks noChangeAspect="1"/>
+          </p:cNvPicPr>
+          <p:nvPr/>
+        </p:nvPicPr>
+        <p:blipFill>
+          <a:blip r:embed="rId5"/>
+          <a:stretch>
+            <a:fillRect/>
+          </a:stretch>
+        </p:blipFill>
+        <p:spPr>
+          <a:xfrm>
+            <a:off x="722742" y="3182478"/>
+            <a:ext cx="237012" cy="237012"/>
+          </a:xfrm>
+          <a:prstGeom prst="rect">
+            <a:avLst/>
+          </a:prstGeom>
+        </p:spPr>
+      </p:pic>
+      <p:sp>
+        <p:nvSpPr>
+          <p:cNvPr id="16" name="Category head 3"/>
+          <p:cNvSpPr txBox="1"/>
+          <p:nvPr/>
+        </p:nvSpPr>
+        <p:spPr>
+          <a:xfrm>
+            <a:off x="1280160" y="2999232"/>
+            <a:ext cx="3840480" cy="274320"/>
+          </a:xfrm>
+          <a:prstGeom prst="rect">
+            <a:avLst/>
+          </a:prstGeom>
+          <a:noFill/>
+          <a:ln/>
+        </p:spPr>
+        <p:txBody>
+          <a:bodyPr wrap="square" lIns="0" tIns="0" rIns="0" bIns="0" rtlCol="0" anchor="ctr"/>
+          <a:lstStyle/>
+          <a:p>
+            <a:pPr marL="0" indent="0">
+              <a:buNone/>
+            </a:pPr>
+            <a:r>
+              <a:rPr lang="en-US" sz="1400" b="1" dirty="0">
+                <a:solidFill>
+                  <a:schemeClr val="tx2"/>
+                </a:solidFill>
+              </a:rPr>
+              <a:t>Works everywhere</a:t>
+            </a:r>
+            <a:endParaRPr lang="en-US" sz="1400" dirty="0"/>
+          </a:p>
+        </p:txBody>
+      </p:sp>
+      <p:sp>
+        <p:nvSpPr>
+          <p:cNvPr id="17" name="Category text 3"/>
+          <p:cNvSpPr txBox="1"/>
+          <p:nvPr/>
+        </p:nvSpPr>
+        <p:spPr>
+          <a:xfrm>
+            <a:off x="1280160" y="3291840"/>
+            <a:ext cx="3840480" cy="320040"/>
+          </a:xfrm>
+          <a:prstGeom prst="rect">
+            <a:avLst/>
+          </a:prstGeom>
+          <a:noFill/>
+          <a:ln/>
+        </p:spPr>
+        <p:txBody>
+          <a:bodyPr wrap="square" lIns="0" tIns="0" rIns="0" bIns="0" rtlCol="0" anchor="t"/>
+          <a:lstStyle/>
+          <a:p>
+            <a:pPr marL="0" indent="0">
+              <a:buNone/>
+            </a:pPr>
+            <a:r>
+              <a:rPr lang="en-US" sz="1200" dirty="0">
+                <a:solidFill>
+                  <a:schemeClr val="tx1"/>
+                </a:solidFill>
+              </a:rPr>
+              <a:t>Charts, limits, filters, reports and AI</a:t>
+            </a:r>
+            <a:endParaRPr lang="en-US" sz="1200" dirty="0"/>
+          </a:p>
+        </p:txBody>
+      </p:sp>
+      <p:sp>
+        <p:nvSpPr>
+          <p:cNvPr id="18" name="Category row 4"/>
+          <p:cNvSpPr/>
+          <p:nvPr/>
+        </p:nvSpPr>
+        <p:spPr>
+          <a:xfrm>
+            <a:off x="457200" y="3794760"/>
+            <a:ext cx="4754880" cy="749808"/>
+          </a:xfrm>
+          <a:prstGeom prst="roundRect">
+            <a:avLst>
+              <a:gd name="adj" fmla="val 14634"/>
+            </a:avLst>
+          </a:prstGeom>
+          <a:solidFill>
+            <a:schemeClr val="bg2"/>
+          </a:solidFill>
+          <a:ln w="12700">
+            <a:solidFill>
+              <a:schemeClr val="bg2"/>
+            </a:solidFill>
+            <a:prstDash val="solid"/>
+          </a:ln>
+        </p:spPr>
+      </p:sp>
+      <p:sp>
+        <p:nvSpPr>
+          <p:cNvPr id="19" name="Category icon 4 circle"/>
+          <p:cNvSpPr/>
+          <p:nvPr/>
+        </p:nvSpPr>
+        <p:spPr>
+          <a:xfrm>
+            <a:off x="594360" y="3922776"/>
+            <a:ext cx="493776" cy="493776"/>
+          </a:xfrm>
+          <a:prstGeom prst="ellipse">
+            <a:avLst/>
+          </a:prstGeom>
+          <a:solidFill>
+            <a:schemeClr val="accent1"/>
+          </a:solidFill>
+          <a:ln w="12700">
+            <a:solidFill>
+              <a:schemeClr val="accent1"/>
+            </a:solidFill>
+            <a:prstDash val="solid"/>
+          </a:ln>
+        </p:spPr>
+      </p:sp>
+      <p:pic>
+        <p:nvPicPr>
+          <p:cNvPr id="20" name="Category icon 4 icon" descr="AI icon 4"/>
+          <p:cNvPicPr>
+            <a:picLocks noChangeAspect="1"/>
+          </p:cNvPicPr>
+          <p:nvPr/>
+        </p:nvPicPr>
+        <p:blipFill>
+          <a:blip r:embed="rId6"/>
+          <a:stretch>
+            <a:fillRect/>
+          </a:stretch>
+        </p:blipFill>
+        <p:spPr>
+          <a:xfrm>
+            <a:off x="722742" y="4051158"/>
+            <a:ext cx="237012" cy="237012"/>
+          </a:xfrm>
+          <a:prstGeom prst="rect">
+            <a:avLst/>
+          </a:prstGeom>
+        </p:spPr>
+      </p:pic>
+      <p:sp>
+        <p:nvSpPr>
+          <p:cNvPr id="21" name="Category head 4"/>
+          <p:cNvSpPr txBox="1"/>
+          <p:nvPr/>
+        </p:nvSpPr>
+        <p:spPr>
+          <a:xfrm>
+            <a:off x="1280160" y="3867912"/>
+            <a:ext cx="3840480" cy="274320"/>
+          </a:xfrm>
+          <a:prstGeom prst="rect">
+            <a:avLst/>
+          </a:prstGeom>
+          <a:noFill/>
+          <a:ln/>
+        </p:spPr>
+        <p:txBody>
+          <a:bodyPr wrap="square" lIns="0" tIns="0" rIns="0" bIns="0" rtlCol="0" anchor="ctr"/>
+          <a:lstStyle/>
+          <a:p>
+            <a:pPr marL="0" indent="0">
+              <a:buNone/>
+            </a:pPr>
+            <a:r>
+              <a:rPr lang="en-US" sz="1400" b="1" dirty="0">
+                <a:solidFill>
+                  <a:schemeClr val="tx2"/>
+                </a:solidFill>
+              </a:rPr>
+              <a:t>Safe delete</a:t>
+            </a:r>
+            <a:endParaRPr lang="en-US" sz="1400" dirty="0"/>
+          </a:p>
+        </p:txBody>
+      </p:sp>
+      <p:sp>
+        <p:nvSpPr>
+          <p:cNvPr id="22" name="Category text 4"/>
+          <p:cNvSpPr txBox="1"/>
+          <p:nvPr/>
+        </p:nvSpPr>
+        <p:spPr>
+          <a:xfrm>
+            <a:off x="1280160" y="4160520"/>
+            <a:ext cx="3840480" cy="320040"/>
+          </a:xfrm>
+          <a:prstGeom prst="rect">
+            <a:avLst/>
+          </a:prstGeom>
+          <a:noFill/>
+          <a:ln/>
+        </p:spPr>
+        <p:txBody>
+          <a:bodyPr wrap="square" lIns="0" tIns="0" rIns="0" bIns="0" rtlCol="0" anchor="t"/>
+          <a:lstStyle/>
+          <a:p>
+            <a:pPr marL="0" indent="0">
+              <a:buNone/>
+            </a:pPr>
+            <a:r>
+              <a:rPr lang="en-US" sz="1200" dirty="0">
+                <a:solidFill>
+                  <a:schemeClr val="tx1"/>
+                </a:solidFill>
+              </a:rPr>
+              <a:t>Expenses move to Other; the limit is removed</a:t>
+            </a:r>
+            <a:endParaRPr lang="en-US" sz="1200" dirty="0"/>
+          </a:p>
+        </p:txBody>
+      </p:sp>
+      <p:sp>
+        <p:nvSpPr>
+          <p:cNvPr id="23" name="Prompt card"/>
+          <p:cNvSpPr/>
+          <p:nvPr/>
+        </p:nvSpPr>
+        <p:spPr>
+          <a:xfrm>
+            <a:off x="5486400" y="1188720"/>
+            <a:ext cx="3200400" cy="3383280"/>
+          </a:xfrm>
+          <a:prstGeom prst="roundRect">
+            <a:avLst>
+              <a:gd name="adj" fmla="val 2857"/>
+            </a:avLst>
+          </a:prstGeom>
+          <a:solidFill>
+            <a:schemeClr val="tx2"/>
+          </a:solidFill>
+          <a:ln w="12700">
+            <a:solidFill>
+              <a:schemeClr val="tx2"/>
+            </a:solidFill>
+            <a:prstDash val="solid"/>
+          </a:ln>
+        </p:spPr>
+      </p:sp>
+      <p:sp>
+        <p:nvSpPr>
+          <p:cNvPr id="24" name="Prompt head"/>
+          <p:cNvSpPr txBox="1"/>
+          <p:nvPr/>
+        </p:nvSpPr>
+        <p:spPr>
+          <a:xfrm>
+            <a:off x="5715000" y="1325880"/>
+            <a:ext cx="2743200" cy="365760"/>
+          </a:xfrm>
+          <a:prstGeom prst="rect">
+            <a:avLst/>
+          </a:prstGeom>
+          <a:noFill/>
+          <a:ln/>
+        </p:spPr>
+        <p:txBody>
+          <a:bodyPr wrap="square" lIns="0" tIns="0" rIns="0" bIns="0" rtlCol="0" anchor="ctr"/>
+          <a:lstStyle/>
+          <a:p>
+            <a:pPr marL="0" indent="0">
+              <a:buNone/>
+            </a:pPr>
+            <a:r>
+              <a:rPr lang="en-US" sz="1700" b="1" dirty="0">
+                <a:solidFill>
+                  <a:schemeClr val="accent2"/>
+                </a:solidFill>
+                <a:latin typeface="Cambria" pitchFamily="34" charset="0"/>
+                <a:ea typeface="Cambria" pitchFamily="34" charset="-122"/>
+                <a:cs typeface="Cambria" pitchFamily="34" charset="-120"/>
+              </a:rPr>
+              <a:t>How it is stored</a:t>
+            </a:r>
+            <a:endParaRPr lang="en-US" sz="1700" dirty="0"/>
+          </a:p>
+        </p:txBody>
+      </p:sp>
+      <p:sp>
+        <p:nvSpPr>
+          <p:cNvPr id="25" name="Prompt list"/>
+          <p:cNvSpPr txBox="1"/>
+          <p:nvPr/>
+        </p:nvSpPr>
+        <p:spPr>
+          <a:xfrm>
+            <a:off x="5715000" y="1828800"/>
+            <a:ext cx="2743200" cy="2651760"/>
+          </a:xfrm>
+          <a:prstGeom prst="rect">
+            <a:avLst/>
+          </a:prstGeom>
+          <a:noFill/>
+          <a:ln/>
+        </p:spPr>
+        <p:txBody>
+          <a:bodyPr wrap="square" lIns="0" tIns="0" rIns="0" bIns="0" rtlCol="0" anchor="t"/>
+          <a:lstStyle/>
+          <a:p>
+            <a:pPr marL="342900" indent="-342900">
+              <a:spcAft>
+                <a:spcPts val="1400"/>
+              </a:spcAft>
+              <a:buSzPct val="100000"/>
+              <a:buChar char="•"/>
+            </a:pPr>
+            <a:r>
+              <a:rPr lang="en-US" sz="1450" dirty="0">
+                <a:solidFill>
+                  <a:schemeClr val="bg1"/>
+                </a:solidFill>
+              </a:rPr>
+              <a:t>Saved as users/{uid}.customCats</a:t>
+            </a:r>
+            <a:endParaRPr lang="en-US" sz="1450" dirty="0"/>
+          </a:p>
+          <a:p>
+            <a:pPr marL="342900" indent="-342900">
+              <a:spcAft>
+                <a:spcPts val="1400"/>
+              </a:spcAft>
+              <a:buSzPct val="100000"/>
+              <a:buChar char="•"/>
+            </a:pPr>
+            <a:r>
+              <a:rPr lang="en-US" sz="1450" dirty="0">
+                <a:solidFill>
+                  <a:schemeClr val="bg1"/>
+                </a:solidFill>
+              </a:rPr>
+              <a:t>Same security rule; no rule change</a:t>
+            </a:r>
+            <a:endParaRPr lang="en-US" sz="1450" dirty="0"/>
+          </a:p>
+          <a:p>
+            <a:pPr marL="342900" indent="-342900">
+              <a:spcAft>
+                <a:spcPts val="1400"/>
+              </a:spcAft>
+              <a:buSzPct val="100000"/>
+              <a:buChar char="•"/>
+            </a:pPr>
+            <a:r>
+              <a:rPr lang="en-US" sz="1450" dirty="0">
+                <a:solidFill>
+                  <a:schemeClr val="bg1"/>
+                </a:solidFill>
+              </a:rPr>
+              <a:t>Names escaped, colours validated</a:t>
+            </a:r>
+            <a:endParaRPr lang="en-US" sz="1450" dirty="0"/>
+          </a:p>
+          <a:p>
+            <a:pPr marL="342900" indent="-342900">
+              <a:spcAft>
+                <a:spcPts val="1400"/>
+              </a:spcAft>
+              <a:buSzPct val="100000"/>
+              <a:buChar char="•"/>
+            </a:pPr>
+            <a:r>
+              <a:rPr lang="en-US" sz="1450" dirty="0">
+                <a:solidFill>
+                  <a:schemeClr val="bg1"/>
+                </a:solidFill>
+              </a:rPr>
+              <a:t>29 automated jsdom checks pass</a:t>
+            </a:r>
+            <a:endParaRPr lang="en-US" sz="1450" dirty="0"/>
+          </a:p>
+        </p:txBody>
+      </p:sp>
+      <p:sp>
+        <p:nvSpPr>
+          <p:cNvPr id="26" name="Slide Number Placeholder 0"/>
+          <p:cNvSpPr>
+            <a:spLocks noGrp="1"/>
+          </p:cNvSpPr>
+          <p:nvPr>
+            <p:ph type="sldNum" sz="quarter" idx="4294967295"/>
+          </p:nvPr>
+        </p:nvSpPr>
+        <p:spPr>
+          <a:xfrm>
+            <a:off x="8229600" y="4754880"/>
+            <a:ext cx="457200" cy="274320"/>
+          </a:xfrm>
+          <a:prstGeom prst="rect">
+            <a:avLst/>
+          </a:prstGeom>
+          <a:extLst>
+            <a:ext uri="{C572A759-6A51-4108-AA02-DFA0A04FC94B}">
+              <ma14:wrappingTextBoxFlag xmlns="" xmlns:ma14="http://schemas.microsoft.com/office/mac/drawingml/2011/main" val="0"/>
+            </a:ext>
+          </a:extLst>
+        </p:spPr>
+        <p:txBody>
+          <a:bodyPr/>
+          <a:lstStyle>
+            <a:lvl1pPr>
+              <a:defRPr sz="1000">
+                <a:solidFill>
+                  <a:schemeClr val="accent6"/>
+                </a:solidFill>
+              </a:defRPr>
+            </a:lvl1pPr>
+          </a:lstStyle>
+          <a:p>
+            <a:pPr algn="r"/>
+            <a:fld id="{F7021451-1387-4CA6-816F-3879F97B5CBC}" type="slidenum">
+              <a:rPr lang="en-US" b="0"/>
+              <a:t>10</a:t>
+            </a:fld>
+            <a:endParaRPr lang="en-US"/>
+          </a:p>
+        </p:txBody>
+      </p:sp>
+    </p:spTree>
+  </p:cSld>
+  <p:clrMapOvr>
+    <a:masterClrMapping/>
+  </p:clrMapOvr>
+</p:sld>
+</file>
+
+<file path=ppt/slides/slide11.xml><?xml version="1.0" encoding="utf-8"?>
 <p:sld xmlns:a="http://schemas.openxmlformats.org/drawingml/2006/main" xmlns:r="http://schemas.openxmlformats.org/officeDocument/2006/relationships" xmlns:p="http://schemas.openxmlformats.org/presentationml/2006/main">
   <p:cSld name="Slide 10">
     <p:spTree>
@@ -2478,7 +3113,7 @@
           <a:bodyPr wrap="square" lIns="0" tIns="0" rIns="0" bIns="0" rtlCol="0" anchor="ctr"/>
           <a:lstStyle/>
           <a:p>
-            <a:pPr indent="0" marL="0">
+            <a:pPr marL="0" indent="0">
               <a:buNone/>
             </a:pPr>
             <a:r>
@@ -2544,7 +3179,7 @@
           <a:bodyPr wrap="square" lIns="0" tIns="0" rIns="0" bIns="0" rtlCol="0" anchor="ctr"/>
           <a:lstStyle/>
           <a:p>
-            <a:pPr indent="0" marL="0">
+            <a:pPr marL="0" indent="0">
               <a:buNone/>
             </a:pPr>
             <a:r>
@@ -2578,15 +3213,27 @@
         </p:nvGraphicFramePr>
         <p:xfrm>
           <a:off x="685800" y="1783080"/>
-          <a:ext cx="4114800" cy="914400"/>
+          <a:ext cx="4114800" cy="1152144"/>
         </p:xfrm>
         <a:graphic>
           <a:graphicData uri="http://schemas.openxmlformats.org/drawingml/2006/table">
             <a:tbl>
               <a:tblPr/>
               <a:tblGrid>
-                <a:gridCol w="1737360"/>
-                <a:gridCol w="2377440"/>
+                <a:gridCol w="1737360">
+                  <a:extLst>
+                    <a:ext uri="{9D8B030D-6E8A-4147-A177-3AD203B41FA5}">
+                      <a16:colId xmlns:a16="http://schemas.microsoft.com/office/drawing/2014/main" val="20000"/>
+                    </a:ext>
+                  </a:extLst>
+                </a:gridCol>
+                <a:gridCol w="2377440">
+                  <a:extLst>
+                    <a:ext uri="{9D8B030D-6E8A-4147-A177-3AD203B41FA5}">
+                      <a16:colId xmlns:a16="http://schemas.microsoft.com/office/drawing/2014/main" val="20001"/>
+                    </a:ext>
+                  </a:extLst>
+                </a:gridCol>
               </a:tblGrid>
               <a:tr h="384048">
                 <a:tc>
@@ -2594,7 +3241,7 @@
                     <a:bodyPr/>
                     <a:lstStyle/>
                     <a:p>
-                      <a:pPr indent="0" marL="0">
+                      <a:pPr marL="0" indent="0">
                         <a:buNone/>
                       </a:pPr>
                       <a:r>
@@ -2608,7 +3255,7 @@
                       <a:endParaRPr lang="en-US" sz="1200" dirty="0"/>
                     </a:p>
                   </a:txBody>
-                  <a:tcPr marL="91440" marR="91440" marT="36576" marB="36576" anchor="ctr">
+                  <a:tcPr marT="36576" marB="36576" anchor="ctr">
                     <a:lnL w="6350" cap="flat" cmpd="sng" algn="ctr">
                       <a:solidFill>
                         <a:srgbClr val="CBD5E1"/>
@@ -2655,7 +3302,7 @@
                     <a:bodyPr/>
                     <a:lstStyle/>
                     <a:p>
-                      <a:pPr indent="0" marL="0">
+                      <a:pPr marL="0" indent="0">
                         <a:buNone/>
                       </a:pPr>
                       <a:r>
@@ -2669,7 +3316,7 @@
                       <a:endParaRPr lang="en-US" sz="1200" dirty="0"/>
                     </a:p>
                   </a:txBody>
-                  <a:tcPr marL="91440" marR="91440" marT="36576" marB="36576" anchor="ctr">
+                  <a:tcPr marT="36576" marB="36576" anchor="ctr">
                     <a:lnL w="6350" cap="flat" cmpd="sng" algn="ctr">
                       <a:solidFill>
                         <a:srgbClr val="CBD5E1"/>
@@ -2711,6 +3358,11 @@
                     </a:solidFill>
                   </a:tcPr>
                 </a:tc>
+                <a:extLst>
+                  <a:ext uri="{0D108BD9-81ED-4DB2-BD59-A6C34878D82A}">
+                    <a16:rowId xmlns:a16="http://schemas.microsoft.com/office/drawing/2014/main" val="10000"/>
+                  </a:ext>
+                </a:extLst>
               </a:tr>
               <a:tr h="384048">
                 <a:tc>
@@ -2718,7 +3370,7 @@
                     <a:bodyPr/>
                     <a:lstStyle/>
                     <a:p>
-                      <a:pPr indent="0" marL="0">
+                      <a:pPr marL="0" indent="0">
                         <a:buNone/>
                       </a:pPr>
                       <a:r>
@@ -2739,7 +3391,7 @@
                       </a:endParaRPr>
                     </a:p>
                   </a:txBody>
-                  <a:tcPr marL="91440" marR="91440" marT="36576" marB="36576" anchor="ctr">
+                  <a:tcPr marT="36576" marB="36576" anchor="ctr">
                     <a:lnL w="6350" cap="flat" cmpd="sng" algn="ctr">
                       <a:solidFill>
                         <a:srgbClr val="CBD5E1"/>
@@ -2786,7 +3438,7 @@
                     <a:bodyPr/>
                     <a:lstStyle/>
                     <a:p>
-                      <a:pPr indent="0" marL="0">
+                      <a:pPr marL="0" indent="0">
                         <a:buNone/>
                       </a:pPr>
                       <a:r>
@@ -2800,7 +3452,7 @@
                       <a:endParaRPr lang="en-US" sz="1200" dirty="0"/>
                     </a:p>
                   </a:txBody>
-                  <a:tcPr marL="91440" marR="91440" marT="36576" marB="36576" anchor="ctr">
+                  <a:tcPr marT="36576" marB="36576" anchor="ctr">
                     <a:lnL w="6350" cap="flat" cmpd="sng" algn="ctr">
                       <a:solidFill>
                         <a:srgbClr val="CBD5E1"/>
@@ -2842,6 +3494,11 @@
                     </a:solidFill>
                   </a:tcPr>
                 </a:tc>
+                <a:extLst>
+                  <a:ext uri="{0D108BD9-81ED-4DB2-BD59-A6C34878D82A}">
+                    <a16:rowId xmlns:a16="http://schemas.microsoft.com/office/drawing/2014/main" val="10001"/>
+                  </a:ext>
+                </a:extLst>
               </a:tr>
               <a:tr h="384048">
                 <a:tc>
@@ -2849,7 +3506,7 @@
                     <a:bodyPr/>
                     <a:lstStyle/>
                     <a:p>
-                      <a:pPr indent="0" marL="0">
+                      <a:pPr marL="0" indent="0">
                         <a:buNone/>
                       </a:pPr>
                       <a:r>
@@ -2870,7 +3527,7 @@
                       </a:endParaRPr>
                     </a:p>
                   </a:txBody>
-                  <a:tcPr marL="91440" marR="91440" marT="36576" marB="36576" anchor="ctr">
+                  <a:tcPr marT="36576" marB="36576" anchor="ctr">
                     <a:lnL w="6350" cap="flat" cmpd="sng" algn="ctr">
                       <a:solidFill>
                         <a:srgbClr val="CBD5E1"/>
@@ -2917,7 +3574,7 @@
                     <a:bodyPr/>
                     <a:lstStyle/>
                     <a:p>
-                      <a:pPr indent="0" marL="0">
+                      <a:pPr marL="0" indent="0">
                         <a:buNone/>
                       </a:pPr>
                       <a:r>
@@ -2931,7 +3588,7 @@
                       <a:endParaRPr lang="en-US" sz="1200" dirty="0"/>
                     </a:p>
                   </a:txBody>
-                  <a:tcPr marL="91440" marR="91440" marT="36576" marB="36576" anchor="ctr">
+                  <a:tcPr marT="36576" marB="36576" anchor="ctr">
                     <a:lnL w="6350" cap="flat" cmpd="sng" algn="ctr">
                       <a:solidFill>
                         <a:srgbClr val="CBD5E1"/>
@@ -2973,6 +3630,11 @@
                     </a:solidFill>
                   </a:tcPr>
                 </a:tc>
+                <a:extLst>
+                  <a:ext uri="{0D108BD9-81ED-4DB2-BD59-A6C34878D82A}">
+                    <a16:rowId xmlns:a16="http://schemas.microsoft.com/office/drawing/2014/main" val="10002"/>
+                  </a:ext>
+                </a:extLst>
               </a:tr>
             </a:tbl>
           </a:graphicData>
@@ -3098,7 +3760,7 @@
             <a:prstDash val="solid"/>
           </a:ln>
           <a:effectLst>
-            <a:outerShdw sx="100000" sy="100000" kx="0" ky="0" algn="bl" rotWithShape="0" blurRad="101600" dist="25400" dir="5400000">
+            <a:outerShdw blurRad="101600" dist="25400" dir="5400000" algn="bl" rotWithShape="0">
               <a:srgbClr val="000000">
                 <a:alpha val="12000"/>
               </a:srgbClr>
@@ -3127,7 +3789,7 @@
           <a:bodyPr wrap="square" lIns="0" tIns="0" rIns="0" bIns="0" rtlCol="0" anchor="ctr"/>
           <a:lstStyle/>
           <a:p>
-            <a:pPr algn="ctr" indent="0" marL="0">
+            <a:pPr marL="0" indent="0" algn="ctr">
               <a:buNone/>
             </a:pPr>
             <a:r>
@@ -3166,7 +3828,7 @@
           <a:bodyPr wrap="square" lIns="0" tIns="0" rIns="0" bIns="0" rtlCol="0" anchor="ctr"/>
           <a:lstStyle/>
           <a:p>
-            <a:pPr algn="ctr" indent="0" marL="0">
+            <a:pPr marL="0" indent="0" algn="ctr">
               <a:buNone/>
             </a:pPr>
             <a:r>
@@ -3295,7 +3957,7 @@
           </a:prstGeom>
           <a:extLst>
             <a:ext uri="{C572A759-6A51-4108-AA02-DFA0A04FC94B}">
-              <ma14:wrappingTextBoxFlag xmlns:ma14="http://schemas.microsoft.com/office/mac/drawingml/2011/main" val="0"/>
+              <ma14:wrappingTextBoxFlag xmlns="" xmlns:ma14="http://schemas.microsoft.com/office/mac/drawingml/2011/main" val="0"/>
             </a:ext>
           </a:extLst>
         </p:spPr>
@@ -3313,7 +3975,7 @@
           <a:p>
             <a:pPr algn="r"/>
             <a:fld id="{F7021451-1387-4CA6-816F-3879F97B5CBC}" type="slidenum">
-              <a:rPr b="0" lang="en-US"/>
+              <a:rPr lang="en-US" b="0"/>
               <a:t>11</a:t>
             </a:fld>
             <a:endParaRPr lang="en-US"/>
@@ -3328,7 +3990,7 @@
 </p:sld>
 </file>
 
-<file path=ppt/slides/slide11.xml><?xml version="1.0" encoding="utf-8"?>
+<file path=ppt/slides/slide12.xml><?xml version="1.0" encoding="utf-8"?>
 <p:sld xmlns:a="http://schemas.openxmlformats.org/drawingml/2006/main" xmlns:r="http://schemas.openxmlformats.org/officeDocument/2006/relationships" xmlns:p="http://schemas.openxmlformats.org/presentationml/2006/main">
   <p:cSld name="Slide 11">
     <p:spTree>
@@ -3366,7 +4028,7 @@
           <a:bodyPr wrap="square" lIns="0" tIns="0" rIns="0" bIns="0" rtlCol="0" anchor="ctr"/>
           <a:lstStyle/>
           <a:p>
-            <a:pPr indent="0" marL="0">
+            <a:pPr marL="0" indent="0">
               <a:buNone/>
             </a:pPr>
             <a:r>
@@ -3457,7 +4119,7 @@
           <a:bodyPr wrap="square" lIns="0" tIns="0" rIns="0" bIns="0" rtlCol="0" anchor="ctr"/>
           <a:lstStyle/>
           <a:p>
-            <a:pPr algn="ctr" indent="0" marL="0">
+            <a:pPr marL="0" indent="0" algn="ctr">
               <a:buNone/>
             </a:pPr>
             <a:r>
@@ -3493,7 +4155,7 @@
           <a:bodyPr wrap="square" lIns="0" tIns="0" rIns="0" bIns="0" rtlCol="0" anchor="ctr"/>
           <a:lstStyle/>
           <a:p>
-            <a:pPr indent="0" marL="0">
+            <a:pPr marL="0" indent="0">
               <a:buNone/>
             </a:pPr>
             <a:r>
@@ -3529,7 +4191,7 @@
           <a:bodyPr wrap="square" lIns="0" tIns="0" rIns="0" bIns="0" rtlCol="0" anchor="t"/>
           <a:lstStyle/>
           <a:p>
-            <a:pPr indent="0" marL="0">
+            <a:pPr marL="0" indent="0">
               <a:buNone/>
             </a:pPr>
             <a:r>
@@ -3617,7 +4279,7 @@
           <a:bodyPr wrap="square" lIns="0" tIns="0" rIns="0" bIns="0" rtlCol="0" anchor="ctr"/>
           <a:lstStyle/>
           <a:p>
-            <a:pPr algn="ctr" indent="0" marL="0">
+            <a:pPr marL="0" indent="0" algn="ctr">
               <a:buNone/>
             </a:pPr>
             <a:r>
@@ -3653,7 +4315,7 @@
           <a:bodyPr wrap="square" lIns="0" tIns="0" rIns="0" bIns="0" rtlCol="0" anchor="ctr"/>
           <a:lstStyle/>
           <a:p>
-            <a:pPr indent="0" marL="0">
+            <a:pPr marL="0" indent="0">
               <a:buNone/>
             </a:pPr>
             <a:r>
@@ -3689,7 +4351,7 @@
           <a:bodyPr wrap="square" lIns="0" tIns="0" rIns="0" bIns="0" rtlCol="0" anchor="t"/>
           <a:lstStyle/>
           <a:p>
-            <a:pPr indent="0" marL="0">
+            <a:pPr marL="0" indent="0">
               <a:buNone/>
             </a:pPr>
             <a:r>
@@ -3777,7 +4439,7 @@
           <a:bodyPr wrap="square" lIns="0" tIns="0" rIns="0" bIns="0" rtlCol="0" anchor="ctr"/>
           <a:lstStyle/>
           <a:p>
-            <a:pPr algn="ctr" indent="0" marL="0">
+            <a:pPr marL="0" indent="0" algn="ctr">
               <a:buNone/>
             </a:pPr>
             <a:r>
@@ -3813,7 +4475,7 @@
           <a:bodyPr wrap="square" lIns="0" tIns="0" rIns="0" bIns="0" rtlCol="0" anchor="ctr"/>
           <a:lstStyle/>
           <a:p>
-            <a:pPr indent="0" marL="0">
+            <a:pPr marL="0" indent="0">
               <a:buNone/>
             </a:pPr>
             <a:r>
@@ -3849,7 +4511,7 @@
           <a:bodyPr wrap="square" lIns="0" tIns="0" rIns="0" bIns="0" rtlCol="0" anchor="t"/>
           <a:lstStyle/>
           <a:p>
-            <a:pPr indent="0" marL="0">
+            <a:pPr marL="0" indent="0">
               <a:buNone/>
             </a:pPr>
             <a:r>
@@ -3885,7 +4547,7 @@
           <a:bodyPr wrap="square" lIns="0" tIns="0" rIns="0" bIns="0" rtlCol="0" anchor="ctr"/>
           <a:lstStyle/>
           <a:p>
-            <a:pPr indent="0" marL="0">
+            <a:pPr marL="0" indent="0">
               <a:buNone/>
             </a:pPr>
             <a:r>
@@ -3948,7 +4610,7 @@
           <a:bodyPr wrap="square" lIns="0" tIns="0" rIns="0" bIns="0" rtlCol="0" anchor="ctr"/>
           <a:lstStyle/>
           <a:p>
-            <a:pPr algn="ctr" indent="0" marL="0">
+            <a:pPr marL="0" indent="0" algn="ctr">
               <a:buNone/>
             </a:pPr>
             <a:r>
@@ -4014,7 +4676,7 @@
           <a:bodyPr wrap="square" lIns="0" tIns="0" rIns="0" bIns="0" rtlCol="0" anchor="ctr"/>
           <a:lstStyle/>
           <a:p>
-            <a:pPr algn="ctr" indent="0" marL="0">
+            <a:pPr marL="0" indent="0" algn="ctr">
               <a:buNone/>
             </a:pPr>
             <a:r>
@@ -4080,7 +4742,7 @@
           <a:bodyPr wrap="square" lIns="0" tIns="0" rIns="0" bIns="0" rtlCol="0" anchor="ctr"/>
           <a:lstStyle/>
           <a:p>
-            <a:pPr algn="ctr" indent="0" marL="0">
+            <a:pPr marL="0" indent="0" algn="ctr">
               <a:buNone/>
             </a:pPr>
             <a:r>
@@ -4118,7 +4780,7 @@
           </a:prstGeom>
           <a:extLst>
             <a:ext uri="{C572A759-6A51-4108-AA02-DFA0A04FC94B}">
-              <ma14:wrappingTextBoxFlag xmlns:ma14="http://schemas.microsoft.com/office/mac/drawingml/2011/main" val="0"/>
+              <ma14:wrappingTextBoxFlag xmlns="" xmlns:ma14="http://schemas.microsoft.com/office/mac/drawingml/2011/main" val="0"/>
             </a:ext>
           </a:extLst>
         </p:spPr>
@@ -4136,7 +4798,7 @@
           <a:p>
             <a:pPr algn="r"/>
             <a:fld id="{F7021451-1387-4CA6-816F-3879F97B5CBC}" type="slidenum">
-              <a:rPr b="0" lang="en-US"/>
+              <a:rPr lang="en-US" b="0"/>
               <a:t>12</a:t>
             </a:fld>
             <a:endParaRPr lang="en-US"/>
@@ -4151,7 +4813,7 @@
 </p:sld>
 </file>
 
-<file path=ppt/slides/slide12.xml><?xml version="1.0" encoding="utf-8"?>
+<file path=ppt/slides/slide13.xml><?xml version="1.0" encoding="utf-8"?>
 <p:sld xmlns:a="http://schemas.openxmlformats.org/drawingml/2006/main" xmlns:r="http://schemas.openxmlformats.org/officeDocument/2006/relationships" xmlns:p="http://schemas.openxmlformats.org/presentationml/2006/main">
   <p:cSld name="Slide 12">
     <p:spTree>
@@ -4189,7 +4851,7 @@
           <a:bodyPr wrap="square" lIns="0" tIns="0" rIns="0" bIns="0" rtlCol="0" anchor="ctr"/>
           <a:lstStyle/>
           <a:p>
-            <a:pPr indent="0" marL="0">
+            <a:pPr marL="0" indent="0">
               <a:buNone/>
             </a:pPr>
             <a:r>
@@ -4282,7 +4944,7 @@
           <a:bodyPr wrap="square" lIns="0" tIns="0" rIns="0" bIns="0" rtlCol="0" anchor="ctr"/>
           <a:lstStyle/>
           <a:p>
-            <a:pPr indent="0" marL="0">
+            <a:pPr marL="0" indent="0">
               <a:buNone/>
             </a:pPr>
             <a:r>
@@ -4321,7 +4983,7 @@
           <a:bodyPr wrap="square" lIns="0" tIns="0" rIns="0" bIns="0" rtlCol="0" anchor="ctr"/>
           <a:lstStyle/>
           <a:p>
-            <a:pPr indent="0" marL="0">
+            <a:pPr marL="0" indent="0">
               <a:buNone/>
             </a:pPr>
             <a:r>
@@ -4619,7 +5281,7 @@
           </a:prstGeom>
           <a:extLst>
             <a:ext uri="{C572A759-6A51-4108-AA02-DFA0A04FC94B}">
-              <ma14:wrappingTextBoxFlag xmlns:ma14="http://schemas.microsoft.com/office/mac/drawingml/2011/main" val="0"/>
+              <ma14:wrappingTextBoxFlag xmlns="" xmlns:ma14="http://schemas.microsoft.com/office/mac/drawingml/2011/main" val="0"/>
             </a:ext>
           </a:extLst>
         </p:spPr>
@@ -4637,7 +5299,7 @@
           <a:p>
             <a:pPr algn="r"/>
             <a:fld id="{F7021451-1387-4CA6-816F-3879F97B5CBC}" type="slidenum">
-              <a:rPr b="0" lang="en-US"/>
+              <a:rPr lang="en-US" b="0"/>
               <a:t>13</a:t>
             </a:fld>
             <a:endParaRPr lang="en-US"/>
@@ -4652,7 +5314,7 @@
 </p:sld>
 </file>
 
-<file path=ppt/slides/slide13.xml><?xml version="1.0" encoding="utf-8"?>
+<file path=ppt/slides/slide14.xml><?xml version="1.0" encoding="utf-8"?>
 <p:sld xmlns:a="http://schemas.openxmlformats.org/drawingml/2006/main" xmlns:r="http://schemas.openxmlformats.org/officeDocument/2006/relationships" xmlns:p="http://schemas.openxmlformats.org/presentationml/2006/main">
   <p:cSld name="Slide 13">
     <p:spTree>
@@ -4717,7 +5379,7 @@
           <a:bodyPr wrap="square" lIns="0" tIns="0" rIns="0" bIns="0" rtlCol="0" anchor="ctr"/>
           <a:lstStyle/>
           <a:p>
-            <a:pPr indent="0" marL="0">
+            <a:pPr marL="0" indent="0">
               <a:buNone/>
             </a:pPr>
             <a:r>
@@ -4756,7 +5418,7 @@
           <a:bodyPr wrap="square" lIns="0" tIns="0" rIns="0" bIns="0" rtlCol="0" anchor="ctr"/>
           <a:lstStyle/>
           <a:p>
-            <a:pPr indent="0" marL="0">
+            <a:pPr marL="0" indent="0">
               <a:buNone/>
             </a:pPr>
             <a:r>
@@ -4792,7 +5454,7 @@
           <a:bodyPr wrap="square" lIns="0" tIns="0" rIns="0" bIns="0" rtlCol="0" anchor="ctr"/>
           <a:lstStyle/>
           <a:p>
-            <a:pPr indent="0" marL="0">
+            <a:pPr marL="0" indent="0">
               <a:buNone/>
             </a:pPr>
             <a:r>
@@ -4815,7 +5477,7 @@
         </p:nvSpPr>
         <p:spPr>
           <a:xfrm>
-            <a:off x="1737360" y="2743200"/>
+            <a:off x="1716888" y="2743200"/>
             <a:ext cx="5943600" cy="365760"/>
           </a:xfrm>
           <a:prstGeom prst="rect">
@@ -4828,18 +5490,19 @@
           <a:bodyPr wrap="square" lIns="0" tIns="0" rIns="0" bIns="0" rtlCol="0" anchor="ctr"/>
           <a:lstStyle/>
           <a:p>
-            <a:pPr indent="0" marL="0">
-              <a:buNone/>
-            </a:pPr>
-            <a:r>
-              <a:rPr lang="en-US" sz="1400" dirty="0">
+            <a:r>
+              <a:rPr lang="en-US" sz="1400" dirty="0" smtClean="0">
                 <a:solidFill>
                   <a:schemeClr val="bg1"/>
                 </a:solidFill>
               </a:rPr>
-              <a:t>https://YOUR_PROJECT_ID.web.app</a:t>
-            </a:r>
-            <a:endParaRPr lang="en-US" sz="1400" dirty="0"/>
+              <a:t>https://budgetbuddy-ai-23447.web.app</a:t>
+            </a:r>
+            <a:endParaRPr lang="en-US" sz="1400" dirty="0">
+              <a:solidFill>
+                <a:schemeClr val="bg1"/>
+              </a:solidFill>
+            </a:endParaRPr>
           </a:p>
         </p:txBody>
       </p:sp>
@@ -4864,7 +5527,7 @@
           <a:bodyPr wrap="square" lIns="0" tIns="0" rIns="0" bIns="0" rtlCol="0" anchor="ctr"/>
           <a:lstStyle/>
           <a:p>
-            <a:pPr indent="0" marL="0">
+            <a:pPr marL="0" indent="0">
               <a:buNone/>
             </a:pPr>
             <a:r>
@@ -4900,16 +5563,29 @@
           <a:bodyPr wrap="square" lIns="0" tIns="0" rIns="0" bIns="0" rtlCol="0" anchor="ctr"/>
           <a:lstStyle/>
           <a:p>
-            <a:pPr indent="0" marL="0">
-              <a:buNone/>
-            </a:pPr>
+            <a:r>
+              <a:rPr lang="en-US" sz="1400" dirty="0" smtClean="0">
+                <a:solidFill>
+                  <a:schemeClr val="bg1"/>
+                </a:solidFill>
+              </a:rPr>
+              <a:t>https</a:t>
+            </a:r>
             <a:r>
               <a:rPr lang="en-US" sz="1400" dirty="0">
                 <a:solidFill>
                   <a:schemeClr val="bg1"/>
                 </a:solidFill>
               </a:rPr>
-              <a:t>https://YOUR_APP.vercel.app</a:t>
+              <a:t>://</a:t>
+            </a:r>
+            <a:r>
+              <a:rPr lang="en-US" sz="1400" dirty="0" smtClean="0">
+                <a:solidFill>
+                  <a:schemeClr val="bg1"/>
+                </a:solidFill>
+              </a:rPr>
+              <a:t>budgetbuddy-ai-xi.vercel.app</a:t>
             </a:r>
             <a:endParaRPr lang="en-US" sz="1400" dirty="0"/>
           </a:p>
@@ -4936,7 +5612,7 @@
           <a:bodyPr wrap="square" lIns="0" tIns="0" rIns="0" bIns="0" rtlCol="0" anchor="ctr"/>
           <a:lstStyle/>
           <a:p>
-            <a:pPr indent="0" marL="0">
+            <a:pPr marL="0" indent="0">
               <a:buNone/>
             </a:pPr>
             <a:r>
@@ -4972,16 +5648,21 @@
           <a:bodyPr wrap="square" lIns="0" tIns="0" rIns="0" bIns="0" rtlCol="0" anchor="ctr"/>
           <a:lstStyle/>
           <a:p>
-            <a:pPr indent="0" marL="0">
-              <a:buNone/>
-            </a:pPr>
+            <a:r>
+              <a:rPr lang="en-US" sz="1400" dirty="0" smtClean="0">
+                <a:solidFill>
+                  <a:schemeClr val="bg1"/>
+                </a:solidFill>
+              </a:rPr>
+              <a:t>https</a:t>
+            </a:r>
             <a:r>
               <a:rPr lang="en-US" sz="1400" dirty="0">
                 <a:solidFill>
                   <a:schemeClr val="bg1"/>
                 </a:solidFill>
               </a:rPr>
-              <a:t>github.com/YOUR_USERNAME/budgetbuddy-ai</a:t>
+              <a:t>://github.com/scientistayat-engineer/BudgetBuddy-AI</a:t>
             </a:r>
             <a:endParaRPr lang="en-US" sz="1400" dirty="0"/>
           </a:p>
@@ -5008,7 +5689,7 @@
           <a:bodyPr wrap="square" lIns="0" tIns="0" rIns="0" bIns="0" rtlCol="0" anchor="ctr"/>
           <a:lstStyle/>
           <a:p>
-            <a:pPr indent="0" marL="0">
+            <a:pPr marL="0" indent="0">
               <a:buNone/>
             </a:pPr>
             <a:r>
@@ -5020,867 +5701,6 @@
               <a:t>Anushay Ayat  |  AI and Data Science  |  SMIT</a:t>
             </a:r>
             <a:endParaRPr lang="en-US" sz="1200" dirty="0"/>
-          </a:p>
-        </p:txBody>
-      </p:sp>
-    </p:spTree>
-  </p:cSld>
-  <p:clrMapOvr>
-    <a:masterClrMapping/>
-  </p:clrMapOvr>
-</p:sld>
-</file>
-
-<file path=ppt/slides/slide14.xml><?xml version="1.0" encoding="utf-8"?>
-<p:sld xmlns:a="http://schemas.openxmlformats.org/drawingml/2006/main" xmlns:r="http://schemas.openxmlformats.org/officeDocument/2006/relationships" xmlns:p="http://schemas.openxmlformats.org/presentationml/2006/main">
-  <p:cSld name="Slide 9">
-    <p:spTree>
-      <p:nvGrpSpPr>
-        <p:cNvPr id="1" name=""/>
-        <p:cNvGrpSpPr/>
-        <p:nvPr/>
-      </p:nvGrpSpPr>
-      <p:grpSpPr>
-        <a:xfrm>
-          <a:off x="0" y="0"/>
-          <a:ext cx="0" cy="0"/>
-          <a:chOff x="0" y="0"/>
-          <a:chExt cx="0" cy="0"/>
-        </a:xfrm>
-      </p:grpSpPr>
-      <p:sp>
-        <p:nvSpPr>
-          <p:cNvPr id="2" name="Title"/>
-          <p:cNvSpPr txBox="1"/>
-          <p:nvPr/>
-        </p:nvSpPr>
-        <p:spPr>
-          <a:xfrm>
-            <a:off x="457200" y="274320"/>
-            <a:ext cx="8229600" cy="685800"/>
-          </a:xfrm>
-          <a:prstGeom prst="rect">
-            <a:avLst/>
-          </a:prstGeom>
-          <a:noFill/>
-          <a:ln/>
-        </p:spPr>
-        <p:txBody>
-          <a:bodyPr wrap="square" lIns="0" tIns="0" rIns="0" bIns="0" rtlCol="0" anchor="ctr"/>
-          <a:lstStyle/>
-          <a:p>
-            <a:pPr indent="0" marL="0">
-              <a:buNone/>
-            </a:pPr>
-            <a:r>
-              <a:rPr lang="en-US" sz="3000" b="1" dirty="0">
-                <a:solidFill>
-                  <a:schemeClr val="tx2"/>
-                </a:solidFill>
-                <a:latin typeface="Cambria" pitchFamily="34" charset="0"/>
-                <a:ea typeface="Cambria" pitchFamily="34" charset="-122"/>
-                <a:cs typeface="Cambria" pitchFamily="34" charset="-120"/>
-              </a:rPr>
-              <a:t>Custom categories</a:t>
-            </a:r>
-            <a:endParaRPr lang="en-US" sz="3000" dirty="0"/>
-          </a:p>
-        </p:txBody>
-      </p:sp>
-      <p:sp>
-        <p:nvSpPr>
-          <p:cNvPr id="3" name="Category row 1"/>
-          <p:cNvSpPr/>
-          <p:nvPr/>
-        </p:nvSpPr>
-        <p:spPr>
-          <a:xfrm>
-            <a:off x="457200" y="1188720"/>
-            <a:ext cx="4754880" cy="749808"/>
-          </a:xfrm>
-          <a:prstGeom prst="roundRect">
-            <a:avLst>
-              <a:gd name="adj" fmla="val 14634"/>
-            </a:avLst>
-          </a:prstGeom>
-          <a:solidFill>
-            <a:schemeClr val="bg2"/>
-          </a:solidFill>
-          <a:ln w="12700">
-            <a:solidFill>
-              <a:schemeClr val="bg2"/>
-            </a:solidFill>
-            <a:prstDash val="solid"/>
-          </a:ln>
-        </p:spPr>
-      </p:sp>
-      <p:sp>
-        <p:nvSpPr>
-          <p:cNvPr id="4" name="Category icon 1 circle"/>
-          <p:cNvSpPr/>
-          <p:nvPr/>
-        </p:nvSpPr>
-        <p:spPr>
-          <a:xfrm>
-            <a:off x="594360" y="1316736"/>
-            <a:ext cx="493776" cy="493776"/>
-          </a:xfrm>
-          <a:prstGeom prst="ellipse">
-            <a:avLst/>
-          </a:prstGeom>
-          <a:solidFill>
-            <a:schemeClr val="accent1"/>
-          </a:solidFill>
-          <a:ln w="12700">
-            <a:solidFill>
-              <a:schemeClr val="accent1"/>
-            </a:solidFill>
-            <a:prstDash val="solid"/>
-          </a:ln>
-        </p:spPr>
-      </p:sp>
-      <p:pic>
-        <p:nvPicPr>
-          <p:cNvPr id="5" name="Category icon 1 icon" descr="AI icon 1">    </p:cNvPr>
-          <p:cNvPicPr>
-            <a:picLocks noChangeAspect="1"/>
-          </p:cNvPicPr>
-          <p:nvPr/>
-        </p:nvPicPr>
-        <p:blipFill>
-          <a:blip r:embed="rId1"/>
-          <a:stretch>
-            <a:fillRect/>
-          </a:stretch>
-        </p:blipFill>
-        <p:spPr>
-          <a:xfrm>
-            <a:off x="722742" y="1445118"/>
-            <a:ext cx="237012" cy="237012"/>
-          </a:xfrm>
-          <a:prstGeom prst="rect">
-            <a:avLst/>
-          </a:prstGeom>
-        </p:spPr>
-      </p:pic>
-      <p:sp>
-        <p:nvSpPr>
-          <p:cNvPr id="6" name="Category head 1"/>
-          <p:cNvSpPr txBox="1"/>
-          <p:nvPr/>
-        </p:nvSpPr>
-        <p:spPr>
-          <a:xfrm>
-            <a:off x="1280160" y="1261872"/>
-            <a:ext cx="3840480" cy="274320"/>
-          </a:xfrm>
-          <a:prstGeom prst="rect">
-            <a:avLst/>
-          </a:prstGeom>
-          <a:noFill/>
-          <a:ln/>
-        </p:spPr>
-        <p:txBody>
-          <a:bodyPr wrap="square" lIns="0" tIns="0" rIns="0" bIns="0" rtlCol="0" anchor="ctr"/>
-          <a:lstStyle/>
-          <a:p>
-            <a:pPr indent="0" marL="0">
-              <a:buNone/>
-            </a:pPr>
-            <a:r>
-              <a:rPr lang="en-US" sz="1400" b="1" dirty="0">
-                <a:solidFill>
-                  <a:schemeClr val="tx2"/>
-                </a:solidFill>
-              </a:rPr>
-              <a:t>Create anywhere</a:t>
-            </a:r>
-            <a:endParaRPr lang="en-US" sz="1400" dirty="0"/>
-          </a:p>
-        </p:txBody>
-      </p:sp>
-      <p:sp>
-        <p:nvSpPr>
-          <p:cNvPr id="7" name="Category text 1"/>
-          <p:cNvSpPr txBox="1"/>
-          <p:nvPr/>
-        </p:nvSpPr>
-        <p:spPr>
-          <a:xfrm>
-            <a:off x="1280160" y="1554480"/>
-            <a:ext cx="3840480" cy="320040"/>
-          </a:xfrm>
-          <a:prstGeom prst="rect">
-            <a:avLst/>
-          </a:prstGeom>
-          <a:noFill/>
-          <a:ln/>
-        </p:spPr>
-        <p:txBody>
-          <a:bodyPr wrap="square" lIns="0" tIns="0" rIns="0" bIns="0" rtlCol="0" anchor="t"/>
-          <a:lstStyle/>
-          <a:p>
-            <a:pPr indent="0" marL="0">
-              <a:buNone/>
-            </a:pPr>
-            <a:r>
-              <a:rPr lang="en-US" sz="1200" dirty="0">
-                <a:solidFill>
-                  <a:schemeClr val="tx1"/>
-                </a:solidFill>
-              </a:rPr>
-              <a:t>New category… in any form, or Manage categories</a:t>
-            </a:r>
-            <a:endParaRPr lang="en-US" sz="1200" dirty="0"/>
-          </a:p>
-        </p:txBody>
-      </p:sp>
-      <p:sp>
-        <p:nvSpPr>
-          <p:cNvPr id="8" name="Category row 2"/>
-          <p:cNvSpPr/>
-          <p:nvPr/>
-        </p:nvSpPr>
-        <p:spPr>
-          <a:xfrm>
-            <a:off x="457200" y="2057400"/>
-            <a:ext cx="4754880" cy="749808"/>
-          </a:xfrm>
-          <a:prstGeom prst="roundRect">
-            <a:avLst>
-              <a:gd name="adj" fmla="val 14634"/>
-            </a:avLst>
-          </a:prstGeom>
-          <a:solidFill>
-            <a:schemeClr val="bg2"/>
-          </a:solidFill>
-          <a:ln w="12700">
-            <a:solidFill>
-              <a:schemeClr val="bg2"/>
-            </a:solidFill>
-            <a:prstDash val="solid"/>
-          </a:ln>
-        </p:spPr>
-      </p:sp>
-      <p:sp>
-        <p:nvSpPr>
-          <p:cNvPr id="9" name="Category icon 2 circle"/>
-          <p:cNvSpPr/>
-          <p:nvPr/>
-        </p:nvSpPr>
-        <p:spPr>
-          <a:xfrm>
-            <a:off x="594360" y="2185416"/>
-            <a:ext cx="493776" cy="493776"/>
-          </a:xfrm>
-          <a:prstGeom prst="ellipse">
-            <a:avLst/>
-          </a:prstGeom>
-          <a:solidFill>
-            <a:schemeClr val="accent1"/>
-          </a:solidFill>
-          <a:ln w="12700">
-            <a:solidFill>
-              <a:schemeClr val="accent1"/>
-            </a:solidFill>
-            <a:prstDash val="solid"/>
-          </a:ln>
-        </p:spPr>
-      </p:sp>
-      <p:pic>
-        <p:nvPicPr>
-          <p:cNvPr id="10" name="Category icon 2 icon" descr="AI icon 2">    </p:cNvPr>
-          <p:cNvPicPr>
-            <a:picLocks noChangeAspect="1"/>
-          </p:cNvPicPr>
-          <p:nvPr/>
-        </p:nvPicPr>
-        <p:blipFill>
-          <a:blip r:embed="rId2"/>
-          <a:stretch>
-            <a:fillRect/>
-          </a:stretch>
-        </p:blipFill>
-        <p:spPr>
-          <a:xfrm>
-            <a:off x="722742" y="2313798"/>
-            <a:ext cx="237012" cy="237012"/>
-          </a:xfrm>
-          <a:prstGeom prst="rect">
-            <a:avLst/>
-          </a:prstGeom>
-        </p:spPr>
-      </p:pic>
-      <p:sp>
-        <p:nvSpPr>
-          <p:cNvPr id="11" name="Category head 2"/>
-          <p:cNvSpPr txBox="1"/>
-          <p:nvPr/>
-        </p:nvSpPr>
-        <p:spPr>
-          <a:xfrm>
-            <a:off x="1280160" y="2130552"/>
-            <a:ext cx="3840480" cy="274320"/>
-          </a:xfrm>
-          <a:prstGeom prst="rect">
-            <a:avLst/>
-          </a:prstGeom>
-          <a:noFill/>
-          <a:ln/>
-        </p:spPr>
-        <p:txBody>
-          <a:bodyPr wrap="square" lIns="0" tIns="0" rIns="0" bIns="0" rtlCol="0" anchor="ctr"/>
-          <a:lstStyle/>
-          <a:p>
-            <a:pPr indent="0" marL="0">
-              <a:buNone/>
-            </a:pPr>
-            <a:r>
-              <a:rPr lang="en-US" sz="1400" b="1" dirty="0">
-                <a:solidFill>
-                  <a:schemeClr val="tx2"/>
-                </a:solidFill>
-              </a:rPr>
-              <a:t>Name and colour</a:t>
-            </a:r>
-            <a:endParaRPr lang="en-US" sz="1400" dirty="0"/>
-          </a:p>
-        </p:txBody>
-      </p:sp>
-      <p:sp>
-        <p:nvSpPr>
-          <p:cNvPr id="12" name="Category text 2"/>
-          <p:cNvSpPr txBox="1"/>
-          <p:nvPr/>
-        </p:nvSpPr>
-        <p:spPr>
-          <a:xfrm>
-            <a:off x="1280160" y="2423160"/>
-            <a:ext cx="3840480" cy="320040"/>
-          </a:xfrm>
-          <a:prstGeom prst="rect">
-            <a:avLst/>
-          </a:prstGeom>
-          <a:noFill/>
-          <a:ln/>
-        </p:spPr>
-        <p:txBody>
-          <a:bodyPr wrap="square" lIns="0" tIns="0" rIns="0" bIns="0" rtlCol="0" anchor="t"/>
-          <a:lstStyle/>
-          <a:p>
-            <a:pPr indent="0" marL="0">
-              <a:buNone/>
-            </a:pPr>
-            <a:r>
-              <a:rPr lang="en-US" sz="1200" dirty="0">
-                <a:solidFill>
-                  <a:schemeClr val="tx1"/>
-                </a:solidFill>
-              </a:rPr>
-              <a:t>Up to 24 characters, 20 per user, no duplicates</a:t>
-            </a:r>
-            <a:endParaRPr lang="en-US" sz="1200" dirty="0"/>
-          </a:p>
-        </p:txBody>
-      </p:sp>
-      <p:sp>
-        <p:nvSpPr>
-          <p:cNvPr id="13" name="Category row 3"/>
-          <p:cNvSpPr/>
-          <p:nvPr/>
-        </p:nvSpPr>
-        <p:spPr>
-          <a:xfrm>
-            <a:off x="457200" y="2926080"/>
-            <a:ext cx="4754880" cy="749808"/>
-          </a:xfrm>
-          <a:prstGeom prst="roundRect">
-            <a:avLst>
-              <a:gd name="adj" fmla="val 14634"/>
-            </a:avLst>
-          </a:prstGeom>
-          <a:solidFill>
-            <a:schemeClr val="bg2"/>
-          </a:solidFill>
-          <a:ln w="12700">
-            <a:solidFill>
-              <a:schemeClr val="bg2"/>
-            </a:solidFill>
-            <a:prstDash val="solid"/>
-          </a:ln>
-        </p:spPr>
-      </p:sp>
-      <p:sp>
-        <p:nvSpPr>
-          <p:cNvPr id="14" name="Category icon 3 circle"/>
-          <p:cNvSpPr/>
-          <p:nvPr/>
-        </p:nvSpPr>
-        <p:spPr>
-          <a:xfrm>
-            <a:off x="594360" y="3054096"/>
-            <a:ext cx="493776" cy="493776"/>
-          </a:xfrm>
-          <a:prstGeom prst="ellipse">
-            <a:avLst/>
-          </a:prstGeom>
-          <a:solidFill>
-            <a:schemeClr val="accent1"/>
-          </a:solidFill>
-          <a:ln w="12700">
-            <a:solidFill>
-              <a:schemeClr val="accent1"/>
-            </a:solidFill>
-            <a:prstDash val="solid"/>
-          </a:ln>
-        </p:spPr>
-      </p:sp>
-      <p:pic>
-        <p:nvPicPr>
-          <p:cNvPr id="15" name="Category icon 3 icon" descr="AI icon 3">    </p:cNvPr>
-          <p:cNvPicPr>
-            <a:picLocks noChangeAspect="1"/>
-          </p:cNvPicPr>
-          <p:nvPr/>
-        </p:nvPicPr>
-        <p:blipFill>
-          <a:blip r:embed="rId3"/>
-          <a:stretch>
-            <a:fillRect/>
-          </a:stretch>
-        </p:blipFill>
-        <p:spPr>
-          <a:xfrm>
-            <a:off x="722742" y="3182478"/>
-            <a:ext cx="237012" cy="237012"/>
-          </a:xfrm>
-          <a:prstGeom prst="rect">
-            <a:avLst/>
-          </a:prstGeom>
-        </p:spPr>
-      </p:pic>
-      <p:sp>
-        <p:nvSpPr>
-          <p:cNvPr id="16" name="Category head 3"/>
-          <p:cNvSpPr txBox="1"/>
-          <p:nvPr/>
-        </p:nvSpPr>
-        <p:spPr>
-          <a:xfrm>
-            <a:off x="1280160" y="2999232"/>
-            <a:ext cx="3840480" cy="274320"/>
-          </a:xfrm>
-          <a:prstGeom prst="rect">
-            <a:avLst/>
-          </a:prstGeom>
-          <a:noFill/>
-          <a:ln/>
-        </p:spPr>
-        <p:txBody>
-          <a:bodyPr wrap="square" lIns="0" tIns="0" rIns="0" bIns="0" rtlCol="0" anchor="ctr"/>
-          <a:lstStyle/>
-          <a:p>
-            <a:pPr indent="0" marL="0">
-              <a:buNone/>
-            </a:pPr>
-            <a:r>
-              <a:rPr lang="en-US" sz="1400" b="1" dirty="0">
-                <a:solidFill>
-                  <a:schemeClr val="tx2"/>
-                </a:solidFill>
-              </a:rPr>
-              <a:t>Works everywhere</a:t>
-            </a:r>
-            <a:endParaRPr lang="en-US" sz="1400" dirty="0"/>
-          </a:p>
-        </p:txBody>
-      </p:sp>
-      <p:sp>
-        <p:nvSpPr>
-          <p:cNvPr id="17" name="Category text 3"/>
-          <p:cNvSpPr txBox="1"/>
-          <p:nvPr/>
-        </p:nvSpPr>
-        <p:spPr>
-          <a:xfrm>
-            <a:off x="1280160" y="3291840"/>
-            <a:ext cx="3840480" cy="320040"/>
-          </a:xfrm>
-          <a:prstGeom prst="rect">
-            <a:avLst/>
-          </a:prstGeom>
-          <a:noFill/>
-          <a:ln/>
-        </p:spPr>
-        <p:txBody>
-          <a:bodyPr wrap="square" lIns="0" tIns="0" rIns="0" bIns="0" rtlCol="0" anchor="t"/>
-          <a:lstStyle/>
-          <a:p>
-            <a:pPr indent="0" marL="0">
-              <a:buNone/>
-            </a:pPr>
-            <a:r>
-              <a:rPr lang="en-US" sz="1200" dirty="0">
-                <a:solidFill>
-                  <a:schemeClr val="tx1"/>
-                </a:solidFill>
-              </a:rPr>
-              <a:t>Charts, limits, filters, reports and AI</a:t>
-            </a:r>
-            <a:endParaRPr lang="en-US" sz="1200" dirty="0"/>
-          </a:p>
-        </p:txBody>
-      </p:sp>
-      <p:sp>
-        <p:nvSpPr>
-          <p:cNvPr id="18" name="Category row 4"/>
-          <p:cNvSpPr/>
-          <p:nvPr/>
-        </p:nvSpPr>
-        <p:spPr>
-          <a:xfrm>
-            <a:off x="457200" y="3794760"/>
-            <a:ext cx="4754880" cy="749808"/>
-          </a:xfrm>
-          <a:prstGeom prst="roundRect">
-            <a:avLst>
-              <a:gd name="adj" fmla="val 14634"/>
-            </a:avLst>
-          </a:prstGeom>
-          <a:solidFill>
-            <a:schemeClr val="bg2"/>
-          </a:solidFill>
-          <a:ln w="12700">
-            <a:solidFill>
-              <a:schemeClr val="bg2"/>
-            </a:solidFill>
-            <a:prstDash val="solid"/>
-          </a:ln>
-        </p:spPr>
-      </p:sp>
-      <p:sp>
-        <p:nvSpPr>
-          <p:cNvPr id="19" name="Category icon 4 circle"/>
-          <p:cNvSpPr/>
-          <p:nvPr/>
-        </p:nvSpPr>
-        <p:spPr>
-          <a:xfrm>
-            <a:off x="594360" y="3922776"/>
-            <a:ext cx="493776" cy="493776"/>
-          </a:xfrm>
-          <a:prstGeom prst="ellipse">
-            <a:avLst/>
-          </a:prstGeom>
-          <a:solidFill>
-            <a:schemeClr val="accent1"/>
-          </a:solidFill>
-          <a:ln w="12700">
-            <a:solidFill>
-              <a:schemeClr val="accent1"/>
-            </a:solidFill>
-            <a:prstDash val="solid"/>
-          </a:ln>
-        </p:spPr>
-      </p:sp>
-      <p:pic>
-        <p:nvPicPr>
-          <p:cNvPr id="20" name="Category icon 4 icon" descr="AI icon 4">    </p:cNvPr>
-          <p:cNvPicPr>
-            <a:picLocks noChangeAspect="1"/>
-          </p:cNvPicPr>
-          <p:nvPr/>
-        </p:nvPicPr>
-        <p:blipFill>
-          <a:blip r:embed="rId4"/>
-          <a:stretch>
-            <a:fillRect/>
-          </a:stretch>
-        </p:blipFill>
-        <p:spPr>
-          <a:xfrm>
-            <a:off x="722742" y="4051158"/>
-            <a:ext cx="237012" cy="237012"/>
-          </a:xfrm>
-          <a:prstGeom prst="rect">
-            <a:avLst/>
-          </a:prstGeom>
-        </p:spPr>
-      </p:pic>
-      <p:sp>
-        <p:nvSpPr>
-          <p:cNvPr id="21" name="Category head 4"/>
-          <p:cNvSpPr txBox="1"/>
-          <p:nvPr/>
-        </p:nvSpPr>
-        <p:spPr>
-          <a:xfrm>
-            <a:off x="1280160" y="3867912"/>
-            <a:ext cx="3840480" cy="274320"/>
-          </a:xfrm>
-          <a:prstGeom prst="rect">
-            <a:avLst/>
-          </a:prstGeom>
-          <a:noFill/>
-          <a:ln/>
-        </p:spPr>
-        <p:txBody>
-          <a:bodyPr wrap="square" lIns="0" tIns="0" rIns="0" bIns="0" rtlCol="0" anchor="ctr"/>
-          <a:lstStyle/>
-          <a:p>
-            <a:pPr indent="0" marL="0">
-              <a:buNone/>
-            </a:pPr>
-            <a:r>
-              <a:rPr lang="en-US" sz="1400" b="1" dirty="0">
-                <a:solidFill>
-                  <a:schemeClr val="tx2"/>
-                </a:solidFill>
-              </a:rPr>
-              <a:t>Safe delete</a:t>
-            </a:r>
-            <a:endParaRPr lang="en-US" sz="1400" dirty="0"/>
-          </a:p>
-        </p:txBody>
-      </p:sp>
-      <p:sp>
-        <p:nvSpPr>
-          <p:cNvPr id="22" name="Category text 4"/>
-          <p:cNvSpPr txBox="1"/>
-          <p:nvPr/>
-        </p:nvSpPr>
-        <p:spPr>
-          <a:xfrm>
-            <a:off x="1280160" y="4160520"/>
-            <a:ext cx="3840480" cy="320040"/>
-          </a:xfrm>
-          <a:prstGeom prst="rect">
-            <a:avLst/>
-          </a:prstGeom>
-          <a:noFill/>
-          <a:ln/>
-        </p:spPr>
-        <p:txBody>
-          <a:bodyPr wrap="square" lIns="0" tIns="0" rIns="0" bIns="0" rtlCol="0" anchor="t"/>
-          <a:lstStyle/>
-          <a:p>
-            <a:pPr indent="0" marL="0">
-              <a:buNone/>
-            </a:pPr>
-            <a:r>
-              <a:rPr lang="en-US" sz="1200" dirty="0">
-                <a:solidFill>
-                  <a:schemeClr val="tx1"/>
-                </a:solidFill>
-              </a:rPr>
-              <a:t>Expenses move to Other; the limit is removed</a:t>
-            </a:r>
-            <a:endParaRPr lang="en-US" sz="1200" dirty="0"/>
-          </a:p>
-        </p:txBody>
-      </p:sp>
-      <p:sp>
-        <p:nvSpPr>
-          <p:cNvPr id="23" name="Prompt card"/>
-          <p:cNvSpPr/>
-          <p:nvPr/>
-        </p:nvSpPr>
-        <p:spPr>
-          <a:xfrm>
-            <a:off x="5486400" y="1188720"/>
-            <a:ext cx="3200400" cy="3383280"/>
-          </a:xfrm>
-          <a:prstGeom prst="roundRect">
-            <a:avLst>
-              <a:gd name="adj" fmla="val 2857"/>
-            </a:avLst>
-          </a:prstGeom>
-          <a:solidFill>
-            <a:schemeClr val="tx2"/>
-          </a:solidFill>
-          <a:ln w="12700">
-            <a:solidFill>
-              <a:schemeClr val="tx2"/>
-            </a:solidFill>
-            <a:prstDash val="solid"/>
-          </a:ln>
-        </p:spPr>
-      </p:sp>
-      <p:sp>
-        <p:nvSpPr>
-          <p:cNvPr id="24" name="Prompt head"/>
-          <p:cNvSpPr txBox="1"/>
-          <p:nvPr/>
-        </p:nvSpPr>
-        <p:spPr>
-          <a:xfrm>
-            <a:off x="5715000" y="1325880"/>
-            <a:ext cx="2743200" cy="365760"/>
-          </a:xfrm>
-          <a:prstGeom prst="rect">
-            <a:avLst/>
-          </a:prstGeom>
-          <a:noFill/>
-          <a:ln/>
-        </p:spPr>
-        <p:txBody>
-          <a:bodyPr wrap="square" lIns="0" tIns="0" rIns="0" bIns="0" rtlCol="0" anchor="ctr"/>
-          <a:lstStyle/>
-          <a:p>
-            <a:pPr indent="0" marL="0">
-              <a:buNone/>
-            </a:pPr>
-            <a:r>
-              <a:rPr lang="en-US" sz="1700" b="1" dirty="0">
-                <a:solidFill>
-                  <a:schemeClr val="accent2"/>
-                </a:solidFill>
-                <a:latin typeface="Cambria" pitchFamily="34" charset="0"/>
-                <a:ea typeface="Cambria" pitchFamily="34" charset="-122"/>
-                <a:cs typeface="Cambria" pitchFamily="34" charset="-120"/>
-              </a:rPr>
-              <a:t>How it is stored</a:t>
-            </a:r>
-            <a:endParaRPr lang="en-US" sz="1700" dirty="0"/>
-          </a:p>
-        </p:txBody>
-      </p:sp>
-      <p:sp>
-        <p:nvSpPr>
-          <p:cNvPr id="25" name="Prompt list"/>
-          <p:cNvSpPr txBox="1"/>
-          <p:nvPr/>
-        </p:nvSpPr>
-        <p:spPr>
-          <a:xfrm>
-            <a:off x="5715000" y="1828800"/>
-            <a:ext cx="2743200" cy="2651760"/>
-          </a:xfrm>
-          <a:prstGeom prst="rect">
-            <a:avLst/>
-          </a:prstGeom>
-          <a:noFill/>
-          <a:ln/>
-        </p:spPr>
-        <p:txBody>
-          <a:bodyPr wrap="square" lIns="0" tIns="0" rIns="0" bIns="0" rtlCol="0" anchor="t"/>
-          <a:lstStyle/>
-          <a:p>
-            <a:pPr marL="342900" indent="-342900">
-              <a:spcAft>
-                <a:spcPts val="1400"/>
-              </a:spcAft>
-              <a:buSzPct val="100000"/>
-              <a:buChar char="•"/>
-            </a:pPr>
-            <a:r>
-              <a:rPr lang="en-US" sz="1450" dirty="0">
-                <a:solidFill>
-                  <a:schemeClr val="bg1"/>
-                </a:solidFill>
-              </a:rPr>
-              <a:t>Saved as users/{uid}.customCats</a:t>
-            </a:r>
-            <a:endParaRPr lang="en-US" sz="1450" dirty="0"/>
-          </a:p>
-          <a:p>
-            <a:pPr marL="342900" indent="-342900">
-              <a:spcAft>
-                <a:spcPts val="1400"/>
-              </a:spcAft>
-              <a:buSzPct val="100000"/>
-              <a:buChar char="•"/>
-            </a:pPr>
-            <a:r>
-              <a:rPr lang="en-US" sz="1450" dirty="0">
-                <a:solidFill>
-                  <a:schemeClr val="bg1"/>
-                </a:solidFill>
-              </a:rPr>
-              <a:t>Same security rule; no rule change</a:t>
-            </a:r>
-            <a:endParaRPr lang="en-US" sz="1450" dirty="0"/>
-          </a:p>
-          <a:p>
-            <a:pPr marL="342900" indent="-342900">
-              <a:spcAft>
-                <a:spcPts val="1400"/>
-              </a:spcAft>
-              <a:buSzPct val="100000"/>
-              <a:buChar char="•"/>
-            </a:pPr>
-            <a:r>
-              <a:rPr lang="en-US" sz="1450" dirty="0">
-                <a:solidFill>
-                  <a:schemeClr val="bg1"/>
-                </a:solidFill>
-              </a:rPr>
-              <a:t>Names escaped, colours validated</a:t>
-            </a:r>
-            <a:endParaRPr lang="en-US" sz="1450" dirty="0"/>
-          </a:p>
-          <a:p>
-            <a:pPr marL="342900" indent="-342900">
-              <a:spcAft>
-                <a:spcPts val="1400"/>
-              </a:spcAft>
-              <a:buSzPct val="100000"/>
-              <a:buChar char="•"/>
-            </a:pPr>
-            <a:r>
-              <a:rPr lang="en-US" sz="1450" dirty="0">
-                <a:solidFill>
-                  <a:schemeClr val="bg1"/>
-                </a:solidFill>
-              </a:rPr>
-              <a:t>29 automated jsdom checks pass</a:t>
-            </a:r>
-            <a:endParaRPr lang="en-US" sz="1450" dirty="0"/>
-          </a:p>
-        </p:txBody>
-      </p:sp>
-      <p:sp>
-        <p:nvSpPr>
-          <p:cNvPr id="25" name="Slide Number Placeholder 0"/>
-          <p:cNvSpPr>
-            <a:spLocks noGrp="1"/>
-          </p:cNvSpPr>
-          <p:nvPr>
-            <p:ph type="sldNum" sz="quarter" idx="4294967295"/>
-          </p:nvPr>
-        </p:nvSpPr>
-        <p:spPr>
-          <a:xfrm>
-            <a:off x="8229600" y="4754880"/>
-            <a:ext cx="457200" cy="274320"/>
-          </a:xfrm>
-          <a:prstGeom prst="rect">
-            <a:avLst/>
-          </a:prstGeom>
-          <a:extLst>
-            <a:ext uri="{C572A759-6A51-4108-AA02-DFA0A04FC94B}">
-              <ma14:wrappingTextBoxFlag xmlns:ma14="http://schemas.microsoft.com/office/mac/drawingml/2011/main" val="0"/>
-            </a:ext>
-          </a:extLst>
-        </p:spPr>
-        <p:txBody>
-          <a:bodyPr/>
-          <a:lstStyle>
-            <a:lvl1pPr>
-              <a:defRPr sz="1000">
-                <a:solidFill>
-                  <a:schemeClr val="accent6"/>
-                </a:solidFill>
-              </a:defRPr>
-            </a:lvl1pPr>
-          </a:lstStyle>
-          <a:p>
-            <a:pPr algn="r"/>
-            <a:fld id="{F7021451-1387-4CA6-816F-3879F97B5CBC}" type="slidenum">
-              <a:rPr b="0" lang="en-US"/>
-              <a:t>10</a:t>
-            </a:fld>
-            <a:endParaRPr lang="en-US"/>
           </a:p>
         </p:txBody>
       </p:sp>
@@ -5930,7 +5750,7 @@
           <a:bodyPr wrap="square" lIns="0" tIns="0" rIns="0" bIns="0" rtlCol="0" anchor="ctr"/>
           <a:lstStyle/>
           <a:p>
-            <a:pPr indent="0" marL="0">
+            <a:pPr marL="0" indent="0">
               <a:buNone/>
             </a:pPr>
             <a:r>
@@ -6002,14 +5822,14 @@
       </p:sp>
       <p:pic>
         <p:nvPicPr>
-          <p:cNvPr id="5" name="Icon 1 icon" descr="Icon 1">    </p:cNvPr>
+          <p:cNvPr id="5" name="Icon 1 icon" descr="Icon 1"/>
           <p:cNvPicPr>
             <a:picLocks noChangeAspect="1"/>
           </p:cNvPicPr>
           <p:nvPr/>
         </p:nvPicPr>
         <p:blipFill>
-          <a:blip r:embed="rId1"/>
+          <a:blip r:embed="rId3"/>
           <a:stretch>
             <a:fillRect/>
           </a:stretch>
@@ -6045,7 +5865,7 @@
           <a:bodyPr wrap="square" lIns="0" tIns="0" rIns="0" bIns="0" rtlCol="0" anchor="ctr"/>
           <a:lstStyle/>
           <a:p>
-            <a:pPr indent="0" marL="0">
+            <a:pPr marL="0" indent="0">
               <a:buNone/>
             </a:pPr>
             <a:r>
@@ -6081,7 +5901,7 @@
           <a:bodyPr wrap="square" lIns="0" tIns="0" rIns="0" bIns="0" rtlCol="0" anchor="t"/>
           <a:lstStyle/>
           <a:p>
-            <a:pPr indent="0" marL="0">
+            <a:pPr marL="0" indent="0">
               <a:buNone/>
             </a:pPr>
             <a:r>
@@ -6150,14 +5970,14 @@
       </p:sp>
       <p:pic>
         <p:nvPicPr>
-          <p:cNvPr id="10" name="Icon 2 icon" descr="Icon 2">    </p:cNvPr>
+          <p:cNvPr id="10" name="Icon 2 icon" descr="Icon 2"/>
           <p:cNvPicPr>
             <a:picLocks noChangeAspect="1"/>
           </p:cNvPicPr>
           <p:nvPr/>
         </p:nvPicPr>
         <p:blipFill>
-          <a:blip r:embed="rId2"/>
+          <a:blip r:embed="rId4"/>
           <a:stretch>
             <a:fillRect/>
           </a:stretch>
@@ -6193,7 +6013,7 @@
           <a:bodyPr wrap="square" lIns="0" tIns="0" rIns="0" bIns="0" rtlCol="0" anchor="ctr"/>
           <a:lstStyle/>
           <a:p>
-            <a:pPr indent="0" marL="0">
+            <a:pPr marL="0" indent="0">
               <a:buNone/>
             </a:pPr>
             <a:r>
@@ -6229,7 +6049,7 @@
           <a:bodyPr wrap="square" lIns="0" tIns="0" rIns="0" bIns="0" rtlCol="0" anchor="t"/>
           <a:lstStyle/>
           <a:p>
-            <a:pPr indent="0" marL="0">
+            <a:pPr marL="0" indent="0">
               <a:buNone/>
             </a:pPr>
             <a:r>
@@ -6298,14 +6118,14 @@
       </p:sp>
       <p:pic>
         <p:nvPicPr>
-          <p:cNvPr id="15" name="Icon 3 icon" descr="Icon 3">    </p:cNvPr>
+          <p:cNvPr id="15" name="Icon 3 icon" descr="Icon 3"/>
           <p:cNvPicPr>
             <a:picLocks noChangeAspect="1"/>
           </p:cNvPicPr>
           <p:nvPr/>
         </p:nvPicPr>
         <p:blipFill>
-          <a:blip r:embed="rId3"/>
+          <a:blip r:embed="rId5"/>
           <a:stretch>
             <a:fillRect/>
           </a:stretch>
@@ -6341,7 +6161,7 @@
           <a:bodyPr wrap="square" lIns="0" tIns="0" rIns="0" bIns="0" rtlCol="0" anchor="ctr"/>
           <a:lstStyle/>
           <a:p>
-            <a:pPr indent="0" marL="0">
+            <a:pPr marL="0" indent="0">
               <a:buNone/>
             </a:pPr>
             <a:r>
@@ -6377,7 +6197,7 @@
           <a:bodyPr wrap="square" lIns="0" tIns="0" rIns="0" bIns="0" rtlCol="0" anchor="t"/>
           <a:lstStyle/>
           <a:p>
-            <a:pPr indent="0" marL="0">
+            <a:pPr marL="0" indent="0">
               <a:buNone/>
             </a:pPr>
             <a:r>
@@ -6413,7 +6233,7 @@
           <a:bodyPr wrap="square" lIns="0" tIns="0" rIns="0" bIns="0" rtlCol="0" anchor="ctr"/>
           <a:lstStyle/>
           <a:p>
-            <a:pPr indent="0" marL="0">
+            <a:pPr marL="0" indent="0">
               <a:buNone/>
             </a:pPr>
             <a:r>
@@ -6424,9 +6244,6 @@
               </a:rPr>
               <a:t>Goal: </a:t>
             </a:r>
-            <a:pPr indent="0" marL="0">
-              <a:buNone/>
-            </a:pPr>
             <a:r>
               <a:rPr lang="en-US" sz="1600" dirty="0">
                 <a:solidFill>
@@ -6459,7 +6276,7 @@
           </a:prstGeom>
           <a:extLst>
             <a:ext uri="{C572A759-6A51-4108-AA02-DFA0A04FC94B}">
-              <ma14:wrappingTextBoxFlag xmlns:ma14="http://schemas.microsoft.com/office/mac/drawingml/2011/main" val="0"/>
+              <ma14:wrappingTextBoxFlag xmlns="" xmlns:ma14="http://schemas.microsoft.com/office/mac/drawingml/2011/main" val="0"/>
             </a:ext>
           </a:extLst>
         </p:spPr>
@@ -6477,7 +6294,7 @@
           <a:p>
             <a:pPr algn="r"/>
             <a:fld id="{F7021451-1387-4CA6-816F-3879F97B5CBC}" type="slidenum">
-              <a:rPr b="0" lang="en-US"/>
+              <a:rPr lang="en-US" b="0"/>
               <a:t>2</a:t>
             </a:fld>
             <a:endParaRPr lang="en-US"/>
@@ -6530,7 +6347,7 @@
           <a:bodyPr wrap="square" lIns="0" tIns="0" rIns="0" bIns="0" rtlCol="0" anchor="ctr"/>
           <a:lstStyle/>
           <a:p>
-            <a:pPr indent="0" marL="0">
+            <a:pPr marL="0" indent="0">
               <a:buNone/>
             </a:pPr>
             <a:r>
@@ -6602,14 +6419,14 @@
       </p:sp>
       <p:pic>
         <p:nvPicPr>
-          <p:cNvPr id="5" name="Feature icon 1 icon" descr="Feature icon 1">    </p:cNvPr>
+          <p:cNvPr id="5" name="Feature icon 1 icon" descr="Feature icon 1"/>
           <p:cNvPicPr>
             <a:picLocks noChangeAspect="1"/>
           </p:cNvPicPr>
           <p:nvPr/>
         </p:nvPicPr>
         <p:blipFill>
-          <a:blip r:embed="rId1"/>
+          <a:blip r:embed="rId3"/>
           <a:stretch>
             <a:fillRect/>
           </a:stretch>
@@ -6645,7 +6462,7 @@
           <a:bodyPr wrap="square" lIns="0" tIns="0" rIns="0" bIns="0" rtlCol="0" anchor="ctr"/>
           <a:lstStyle/>
           <a:p>
-            <a:pPr indent="0" marL="0">
+            <a:pPr marL="0" indent="0">
               <a:buNone/>
             </a:pPr>
             <a:r>
@@ -6681,7 +6498,7 @@
           <a:bodyPr wrap="square" lIns="0" tIns="0" rIns="0" bIns="0" rtlCol="0" anchor="t"/>
           <a:lstStyle/>
           <a:p>
-            <a:pPr indent="0" marL="0">
+            <a:pPr marL="0" indent="0">
               <a:buNone/>
             </a:pPr>
             <a:r>
@@ -6750,14 +6567,14 @@
       </p:sp>
       <p:pic>
         <p:nvPicPr>
-          <p:cNvPr id="10" name="Feature icon 2 icon" descr="Feature icon 2">    </p:cNvPr>
+          <p:cNvPr id="10" name="Feature icon 2 icon" descr="Feature icon 2"/>
           <p:cNvPicPr>
             <a:picLocks noChangeAspect="1"/>
           </p:cNvPicPr>
           <p:nvPr/>
         </p:nvPicPr>
         <p:blipFill>
-          <a:blip r:embed="rId2"/>
+          <a:blip r:embed="rId4"/>
           <a:stretch>
             <a:fillRect/>
           </a:stretch>
@@ -6793,7 +6610,7 @@
           <a:bodyPr wrap="square" lIns="0" tIns="0" rIns="0" bIns="0" rtlCol="0" anchor="ctr"/>
           <a:lstStyle/>
           <a:p>
-            <a:pPr indent="0" marL="0">
+            <a:pPr marL="0" indent="0">
               <a:buNone/>
             </a:pPr>
             <a:r>
@@ -6829,7 +6646,7 @@
           <a:bodyPr wrap="square" lIns="0" tIns="0" rIns="0" bIns="0" rtlCol="0" anchor="t"/>
           <a:lstStyle/>
           <a:p>
-            <a:pPr indent="0" marL="0">
+            <a:pPr marL="0" indent="0">
               <a:buNone/>
             </a:pPr>
             <a:r>
@@ -6898,14 +6715,14 @@
       </p:sp>
       <p:pic>
         <p:nvPicPr>
-          <p:cNvPr id="15" name="Feature icon 3 icon" descr="Feature icon 3">    </p:cNvPr>
+          <p:cNvPr id="15" name="Feature icon 3 icon" descr="Feature icon 3"/>
           <p:cNvPicPr>
             <a:picLocks noChangeAspect="1"/>
           </p:cNvPicPr>
           <p:nvPr/>
         </p:nvPicPr>
         <p:blipFill>
-          <a:blip r:embed="rId3"/>
+          <a:blip r:embed="rId5"/>
           <a:stretch>
             <a:fillRect/>
           </a:stretch>
@@ -6941,7 +6758,7 @@
           <a:bodyPr wrap="square" lIns="0" tIns="0" rIns="0" bIns="0" rtlCol="0" anchor="ctr"/>
           <a:lstStyle/>
           <a:p>
-            <a:pPr indent="0" marL="0">
+            <a:pPr marL="0" indent="0">
               <a:buNone/>
             </a:pPr>
             <a:r>
@@ -6977,7 +6794,7 @@
           <a:bodyPr wrap="square" lIns="0" tIns="0" rIns="0" bIns="0" rtlCol="0" anchor="t"/>
           <a:lstStyle/>
           <a:p>
-            <a:pPr indent="0" marL="0">
+            <a:pPr marL="0" indent="0">
               <a:buNone/>
             </a:pPr>
             <a:r>
@@ -7046,14 +6863,14 @@
       </p:sp>
       <p:pic>
         <p:nvPicPr>
-          <p:cNvPr id="20" name="Feature icon 4 icon" descr="Feature icon 4">    </p:cNvPr>
+          <p:cNvPr id="20" name="Feature icon 4 icon" descr="Feature icon 4"/>
           <p:cNvPicPr>
             <a:picLocks noChangeAspect="1"/>
           </p:cNvPicPr>
           <p:nvPr/>
         </p:nvPicPr>
         <p:blipFill>
-          <a:blip r:embed="rId4"/>
+          <a:blip r:embed="rId6"/>
           <a:stretch>
             <a:fillRect/>
           </a:stretch>
@@ -7089,7 +6906,7 @@
           <a:bodyPr wrap="square" lIns="0" tIns="0" rIns="0" bIns="0" rtlCol="0" anchor="ctr"/>
           <a:lstStyle/>
           <a:p>
-            <a:pPr indent="0" marL="0">
+            <a:pPr marL="0" indent="0">
               <a:buNone/>
             </a:pPr>
             <a:r>
@@ -7125,7 +6942,7 @@
           <a:bodyPr wrap="square" lIns="0" tIns="0" rIns="0" bIns="0" rtlCol="0" anchor="t"/>
           <a:lstStyle/>
           <a:p>
-            <a:pPr indent="0" marL="0">
+            <a:pPr marL="0" indent="0">
               <a:buNone/>
             </a:pPr>
             <a:r>
@@ -7194,14 +7011,14 @@
       </p:sp>
       <p:pic>
         <p:nvPicPr>
-          <p:cNvPr id="25" name="Feature icon 5 icon" descr="Feature icon 5">    </p:cNvPr>
+          <p:cNvPr id="25" name="Feature icon 5 icon" descr="Feature icon 5"/>
           <p:cNvPicPr>
             <a:picLocks noChangeAspect="1"/>
           </p:cNvPicPr>
           <p:nvPr/>
         </p:nvPicPr>
         <p:blipFill>
-          <a:blip r:embed="rId5"/>
+          <a:blip r:embed="rId7"/>
           <a:stretch>
             <a:fillRect/>
           </a:stretch>
@@ -7237,7 +7054,7 @@
           <a:bodyPr wrap="square" lIns="0" tIns="0" rIns="0" bIns="0" rtlCol="0" anchor="ctr"/>
           <a:lstStyle/>
           <a:p>
-            <a:pPr indent="0" marL="0">
+            <a:pPr marL="0" indent="0">
               <a:buNone/>
             </a:pPr>
             <a:r>
@@ -7273,7 +7090,7 @@
           <a:bodyPr wrap="square" lIns="0" tIns="0" rIns="0" bIns="0" rtlCol="0" anchor="t"/>
           <a:lstStyle/>
           <a:p>
-            <a:pPr indent="0" marL="0">
+            <a:pPr marL="0" indent="0">
               <a:buNone/>
             </a:pPr>
             <a:r>
@@ -7342,14 +7159,14 @@
       </p:sp>
       <p:pic>
         <p:nvPicPr>
-          <p:cNvPr id="30" name="Feature icon 6 icon" descr="Feature icon 6">    </p:cNvPr>
+          <p:cNvPr id="30" name="Feature icon 6 icon" descr="Feature icon 6"/>
           <p:cNvPicPr>
             <a:picLocks noChangeAspect="1"/>
           </p:cNvPicPr>
           <p:nvPr/>
         </p:nvPicPr>
         <p:blipFill>
-          <a:blip r:embed="rId6"/>
+          <a:blip r:embed="rId8"/>
           <a:stretch>
             <a:fillRect/>
           </a:stretch>
@@ -7385,7 +7202,7 @@
           <a:bodyPr wrap="square" lIns="0" tIns="0" rIns="0" bIns="0" rtlCol="0" anchor="ctr"/>
           <a:lstStyle/>
           <a:p>
-            <a:pPr indent="0" marL="0">
+            <a:pPr marL="0" indent="0">
               <a:buNone/>
             </a:pPr>
             <a:r>
@@ -7421,7 +7238,7 @@
           <a:bodyPr wrap="square" lIns="0" tIns="0" rIns="0" bIns="0" rtlCol="0" anchor="t"/>
           <a:lstStyle/>
           <a:p>
-            <a:pPr indent="0" marL="0">
+            <a:pPr marL="0" indent="0">
               <a:buNone/>
             </a:pPr>
             <a:r>
@@ -7438,7 +7255,7 @@
       </p:sp>
       <p:sp>
         <p:nvSpPr>
-          <p:cNvPr id="25" name="Slide Number Placeholder 0"/>
+          <p:cNvPr id="33" name="Slide Number Placeholder 0"/>
           <p:cNvSpPr>
             <a:spLocks noGrp="1"/>
           </p:cNvSpPr>
@@ -7456,7 +7273,7 @@
           </a:prstGeom>
           <a:extLst>
             <a:ext uri="{C572A759-6A51-4108-AA02-DFA0A04FC94B}">
-              <ma14:wrappingTextBoxFlag xmlns:ma14="http://schemas.microsoft.com/office/mac/drawingml/2011/main" val="0"/>
+              <ma14:wrappingTextBoxFlag xmlns="" xmlns:ma14="http://schemas.microsoft.com/office/mac/drawingml/2011/main" val="0"/>
             </a:ext>
           </a:extLst>
         </p:spPr>
@@ -7474,7 +7291,7 @@
           <a:p>
             <a:pPr algn="r"/>
             <a:fld id="{F7021451-1387-4CA6-816F-3879F97B5CBC}" type="slidenum">
-              <a:rPr b="0" lang="en-US"/>
+              <a:rPr lang="en-US" b="0"/>
               <a:t>3</a:t>
             </a:fld>
             <a:endParaRPr lang="en-US"/>
@@ -7527,7 +7344,7 @@
           <a:bodyPr wrap="square" lIns="0" tIns="0" rIns="0" bIns="0" rtlCol="0" anchor="ctr"/>
           <a:lstStyle/>
           <a:p>
-            <a:pPr indent="0" marL="0">
+            <a:pPr marL="0" indent="0">
               <a:buNone/>
             </a:pPr>
             <a:r>
@@ -7561,16 +7378,34 @@
         </p:nvGraphicFramePr>
         <p:xfrm>
           <a:off x="457200" y="1188720"/>
-          <a:ext cx="8229600" cy="914400"/>
+          <a:ext cx="8229600" cy="3145536"/>
         </p:xfrm>
         <a:graphic>
           <a:graphicData uri="http://schemas.openxmlformats.org/drawingml/2006/table">
             <a:tbl>
               <a:tblPr/>
               <a:tblGrid>
-                <a:gridCol w="3657600"/>
-                <a:gridCol w="3566160"/>
-                <a:gridCol w="1005840"/>
+                <a:gridCol w="3657600">
+                  <a:extLst>
+                    <a:ext uri="{9D8B030D-6E8A-4147-A177-3AD203B41FA5}">
+                      <a16:colId xmlns:a16="http://schemas.microsoft.com/office/drawing/2014/main" val="20000"/>
+                    </a:ext>
+                  </a:extLst>
+                </a:gridCol>
+                <a:gridCol w="3566160">
+                  <a:extLst>
+                    <a:ext uri="{9D8B030D-6E8A-4147-A177-3AD203B41FA5}">
+                      <a16:colId xmlns:a16="http://schemas.microsoft.com/office/drawing/2014/main" val="20001"/>
+                    </a:ext>
+                  </a:extLst>
+                </a:gridCol>
+                <a:gridCol w="1005840">
+                  <a:extLst>
+                    <a:ext uri="{9D8B030D-6E8A-4147-A177-3AD203B41FA5}">
+                      <a16:colId xmlns:a16="http://schemas.microsoft.com/office/drawing/2014/main" val="20002"/>
+                    </a:ext>
+                  </a:extLst>
+                </a:gridCol>
               </a:tblGrid>
               <a:tr h="393192">
                 <a:tc>
@@ -7578,7 +7413,7 @@
                     <a:bodyPr/>
                     <a:lstStyle/>
                     <a:p>
-                      <a:pPr indent="0" marL="0">
+                      <a:pPr marL="0" indent="0">
                         <a:buNone/>
                       </a:pPr>
                       <a:r>
@@ -7615,7 +7450,7 @@
                     <a:bodyPr/>
                     <a:lstStyle/>
                     <a:p>
-                      <a:pPr indent="0" marL="0">
+                      <a:pPr marL="0" indent="0">
                         <a:buNone/>
                       </a:pPr>
                       <a:r>
@@ -7652,7 +7487,7 @@
                     <a:bodyPr/>
                     <a:lstStyle/>
                     <a:p>
-                      <a:pPr indent="0" marL="0">
+                      <a:pPr marL="0" indent="0">
                         <a:buNone/>
                       </a:pPr>
                       <a:r>
@@ -7684,6 +7519,11 @@
                     </a:solidFill>
                   </a:tcPr>
                 </a:tc>
+                <a:extLst>
+                  <a:ext uri="{0D108BD9-81ED-4DB2-BD59-A6C34878D82A}">
+                    <a16:rowId xmlns:a16="http://schemas.microsoft.com/office/drawing/2014/main" val="10000"/>
+                  </a:ext>
+                </a:extLst>
               </a:tr>
               <a:tr h="393192">
                 <a:tc>
@@ -7691,7 +7531,7 @@
                     <a:bodyPr/>
                     <a:lstStyle/>
                     <a:p>
-                      <a:pPr indent="0" marL="0">
+                      <a:pPr marL="0" indent="0">
                         <a:buNone/>
                       </a:pPr>
                       <a:r>
@@ -7728,7 +7568,7 @@
                     <a:bodyPr/>
                     <a:lstStyle/>
                     <a:p>
-                      <a:pPr indent="0" marL="0">
+                      <a:pPr marL="0" indent="0">
                         <a:buNone/>
                       </a:pPr>
                       <a:r>
@@ -7765,7 +7605,7 @@
                     <a:bodyPr/>
                     <a:lstStyle/>
                     <a:p>
-                      <a:pPr algn="ctr" indent="0" marL="0">
+                      <a:pPr marL="0" indent="0" algn="ctr">
                         <a:buNone/>
                       </a:pPr>
                       <a:r>
@@ -7797,6 +7637,11 @@
                     </a:solidFill>
                   </a:tcPr>
                 </a:tc>
+                <a:extLst>
+                  <a:ext uri="{0D108BD9-81ED-4DB2-BD59-A6C34878D82A}">
+                    <a16:rowId xmlns:a16="http://schemas.microsoft.com/office/drawing/2014/main" val="10001"/>
+                  </a:ext>
+                </a:extLst>
               </a:tr>
               <a:tr h="393192">
                 <a:tc>
@@ -7804,7 +7649,7 @@
                     <a:bodyPr/>
                     <a:lstStyle/>
                     <a:p>
-                      <a:pPr indent="0" marL="0">
+                      <a:pPr marL="0" indent="0">
                         <a:buNone/>
                       </a:pPr>
                       <a:r>
@@ -7841,7 +7686,7 @@
                     <a:bodyPr/>
                     <a:lstStyle/>
                     <a:p>
-                      <a:pPr indent="0" marL="0">
+                      <a:pPr marL="0" indent="0">
                         <a:buNone/>
                       </a:pPr>
                       <a:r>
@@ -7878,7 +7723,7 @@
                     <a:bodyPr/>
                     <a:lstStyle/>
                     <a:p>
-                      <a:pPr algn="ctr" indent="0" marL="0">
+                      <a:pPr marL="0" indent="0" algn="ctr">
                         <a:buNone/>
                       </a:pPr>
                       <a:r>
@@ -7910,6 +7755,11 @@
                     </a:solidFill>
                   </a:tcPr>
                 </a:tc>
+                <a:extLst>
+                  <a:ext uri="{0D108BD9-81ED-4DB2-BD59-A6C34878D82A}">
+                    <a16:rowId xmlns:a16="http://schemas.microsoft.com/office/drawing/2014/main" val="10002"/>
+                  </a:ext>
+                </a:extLst>
               </a:tr>
               <a:tr h="393192">
                 <a:tc>
@@ -7917,7 +7767,7 @@
                     <a:bodyPr/>
                     <a:lstStyle/>
                     <a:p>
-                      <a:pPr indent="0" marL="0">
+                      <a:pPr marL="0" indent="0">
                         <a:buNone/>
                       </a:pPr>
                       <a:r>
@@ -7954,7 +7804,7 @@
                     <a:bodyPr/>
                     <a:lstStyle/>
                     <a:p>
-                      <a:pPr indent="0" marL="0">
+                      <a:pPr marL="0" indent="0">
                         <a:buNone/>
                       </a:pPr>
                       <a:r>
@@ -7991,7 +7841,7 @@
                     <a:bodyPr/>
                     <a:lstStyle/>
                     <a:p>
-                      <a:pPr algn="ctr" indent="0" marL="0">
+                      <a:pPr marL="0" indent="0" algn="ctr">
                         <a:buNone/>
                       </a:pPr>
                       <a:r>
@@ -8023,6 +7873,11 @@
                     </a:solidFill>
                   </a:tcPr>
                 </a:tc>
+                <a:extLst>
+                  <a:ext uri="{0D108BD9-81ED-4DB2-BD59-A6C34878D82A}">
+                    <a16:rowId xmlns:a16="http://schemas.microsoft.com/office/drawing/2014/main" val="10003"/>
+                  </a:ext>
+                </a:extLst>
               </a:tr>
               <a:tr h="393192">
                 <a:tc>
@@ -8030,7 +7885,7 @@
                     <a:bodyPr/>
                     <a:lstStyle/>
                     <a:p>
-                      <a:pPr indent="0" marL="0">
+                      <a:pPr marL="0" indent="0">
                         <a:buNone/>
                       </a:pPr>
                       <a:r>
@@ -8067,7 +7922,7 @@
                     <a:bodyPr/>
                     <a:lstStyle/>
                     <a:p>
-                      <a:pPr indent="0" marL="0">
+                      <a:pPr marL="0" indent="0">
                         <a:buNone/>
                       </a:pPr>
                       <a:r>
@@ -8104,7 +7959,7 @@
                     <a:bodyPr/>
                     <a:lstStyle/>
                     <a:p>
-                      <a:pPr algn="ctr" indent="0" marL="0">
+                      <a:pPr marL="0" indent="0" algn="ctr">
                         <a:buNone/>
                       </a:pPr>
                       <a:r>
@@ -8136,6 +7991,11 @@
                     </a:solidFill>
                   </a:tcPr>
                 </a:tc>
+                <a:extLst>
+                  <a:ext uri="{0D108BD9-81ED-4DB2-BD59-A6C34878D82A}">
+                    <a16:rowId xmlns:a16="http://schemas.microsoft.com/office/drawing/2014/main" val="10004"/>
+                  </a:ext>
+                </a:extLst>
               </a:tr>
               <a:tr h="393192">
                 <a:tc>
@@ -8143,7 +8003,7 @@
                     <a:bodyPr/>
                     <a:lstStyle/>
                     <a:p>
-                      <a:pPr indent="0" marL="0">
+                      <a:pPr marL="0" indent="0">
                         <a:buNone/>
                       </a:pPr>
                       <a:r>
@@ -8180,7 +8040,7 @@
                     <a:bodyPr/>
                     <a:lstStyle/>
                     <a:p>
-                      <a:pPr indent="0" marL="0">
+                      <a:pPr marL="0" indent="0">
                         <a:buNone/>
                       </a:pPr>
                       <a:r>
@@ -8217,7 +8077,7 @@
                     <a:bodyPr/>
                     <a:lstStyle/>
                     <a:p>
-                      <a:pPr algn="ctr" indent="0" marL="0">
+                      <a:pPr marL="0" indent="0" algn="ctr">
                         <a:buNone/>
                       </a:pPr>
                       <a:r>
@@ -8249,6 +8109,11 @@
                     </a:solidFill>
                   </a:tcPr>
                 </a:tc>
+                <a:extLst>
+                  <a:ext uri="{0D108BD9-81ED-4DB2-BD59-A6C34878D82A}">
+                    <a16:rowId xmlns:a16="http://schemas.microsoft.com/office/drawing/2014/main" val="10005"/>
+                  </a:ext>
+                </a:extLst>
               </a:tr>
               <a:tr h="393192">
                 <a:tc>
@@ -8256,7 +8121,7 @@
                     <a:bodyPr/>
                     <a:lstStyle/>
                     <a:p>
-                      <a:pPr indent="0" marL="0">
+                      <a:pPr marL="0" indent="0">
                         <a:buNone/>
                       </a:pPr>
                       <a:r>
@@ -8293,7 +8158,7 @@
                     <a:bodyPr/>
                     <a:lstStyle/>
                     <a:p>
-                      <a:pPr indent="0" marL="0">
+                      <a:pPr marL="0" indent="0">
                         <a:buNone/>
                       </a:pPr>
                       <a:r>
@@ -8330,7 +8195,7 @@
                     <a:bodyPr/>
                     <a:lstStyle/>
                     <a:p>
-                      <a:pPr algn="ctr" indent="0" marL="0">
+                      <a:pPr marL="0" indent="0" algn="ctr">
                         <a:buNone/>
                       </a:pPr>
                       <a:r>
@@ -8362,6 +8227,11 @@
                     </a:solidFill>
                   </a:tcPr>
                 </a:tc>
+                <a:extLst>
+                  <a:ext uri="{0D108BD9-81ED-4DB2-BD59-A6C34878D82A}">
+                    <a16:rowId xmlns:a16="http://schemas.microsoft.com/office/drawing/2014/main" val="10006"/>
+                  </a:ext>
+                </a:extLst>
               </a:tr>
               <a:tr h="393192">
                 <a:tc>
@@ -8369,7 +8239,7 @@
                     <a:bodyPr/>
                     <a:lstStyle/>
                     <a:p>
-                      <a:pPr indent="0" marL="0">
+                      <a:pPr marL="0" indent="0">
                         <a:buNone/>
                       </a:pPr>
                       <a:r>
@@ -8406,7 +8276,7 @@
                     <a:bodyPr/>
                     <a:lstStyle/>
                     <a:p>
-                      <a:pPr indent="0" marL="0">
+                      <a:pPr marL="0" indent="0">
                         <a:buNone/>
                       </a:pPr>
                       <a:r>
@@ -8443,7 +8313,7 @@
                     <a:bodyPr/>
                     <a:lstStyle/>
                     <a:p>
-                      <a:pPr algn="ctr" indent="0" marL="0">
+                      <a:pPr marL="0" indent="0" algn="ctr">
                         <a:buNone/>
                       </a:pPr>
                       <a:r>
@@ -8475,6 +8345,11 @@
                     </a:solidFill>
                   </a:tcPr>
                 </a:tc>
+                <a:extLst>
+                  <a:ext uri="{0D108BD9-81ED-4DB2-BD59-A6C34878D82A}">
+                    <a16:rowId xmlns:a16="http://schemas.microsoft.com/office/drawing/2014/main" val="10007"/>
+                  </a:ext>
+                </a:extLst>
               </a:tr>
             </a:tbl>
           </a:graphicData>
@@ -8500,7 +8375,7 @@
           </a:prstGeom>
           <a:extLst>
             <a:ext uri="{C572A759-6A51-4108-AA02-DFA0A04FC94B}">
-              <ma14:wrappingTextBoxFlag xmlns:ma14="http://schemas.microsoft.com/office/mac/drawingml/2011/main" val="0"/>
+              <ma14:wrappingTextBoxFlag xmlns="" xmlns:ma14="http://schemas.microsoft.com/office/mac/drawingml/2011/main" val="0"/>
             </a:ext>
           </a:extLst>
         </p:spPr>
@@ -8518,7 +8393,7 @@
           <a:p>
             <a:pPr algn="r"/>
             <a:fld id="{F7021451-1387-4CA6-816F-3879F97B5CBC}" type="slidenum">
-              <a:rPr b="0" lang="en-US"/>
+              <a:rPr lang="en-US" b="0"/>
               <a:t>4</a:t>
             </a:fld>
             <a:endParaRPr lang="en-US"/>
@@ -8571,7 +8446,7 @@
           <a:bodyPr wrap="square" lIns="0" tIns="0" rIns="0" bIns="0" rtlCol="0" anchor="ctr"/>
           <a:lstStyle/>
           <a:p>
-            <a:pPr indent="0" marL="0">
+            <a:pPr marL="0" indent="0">
               <a:buNone/>
             </a:pPr>
             <a:r>
@@ -8618,14 +8493,14 @@
       </p:sp>
       <p:pic>
         <p:nvPicPr>
-          <p:cNvPr id="4" name="Architecture diagram" descr="Architecture diagram: user, frontend, Firebase Auth, Firestore, FastAPI, Groq">    </p:cNvPr>
+          <p:cNvPr id="4" name="Architecture diagram" descr="Architecture diagram: user, frontend, Firebase Auth, Firestore, FastAPI, Groq"/>
           <p:cNvPicPr>
             <a:picLocks noChangeAspect="1"/>
           </p:cNvPicPr>
           <p:nvPr/>
         </p:nvPicPr>
         <p:blipFill>
-          <a:blip r:embed="rId1"/>
+          <a:blip r:embed="rId3"/>
           <a:stretch>
             <a:fillRect/>
           </a:stretch>
@@ -8686,7 +8561,7 @@
           <a:bodyPr wrap="square" lIns="0" tIns="0" rIns="0" bIns="0" rtlCol="0" anchor="ctr"/>
           <a:lstStyle/>
           <a:p>
-            <a:pPr algn="ctr" indent="0" marL="0">
+            <a:pPr marL="0" indent="0" algn="ctr">
               <a:buNone/>
             </a:pPr>
             <a:r>
@@ -8722,7 +8597,7 @@
           <a:bodyPr wrap="square" lIns="0" tIns="0" rIns="0" bIns="0" rtlCol="0" anchor="ctr"/>
           <a:lstStyle/>
           <a:p>
-            <a:pPr indent="0" marL="0">
+            <a:pPr marL="0" indent="0">
               <a:buNone/>
             </a:pPr>
             <a:r>
@@ -8758,7 +8633,7 @@
           <a:bodyPr wrap="square" lIns="0" tIns="0" rIns="0" bIns="0" rtlCol="0" anchor="t"/>
           <a:lstStyle/>
           <a:p>
-            <a:pPr indent="0" marL="0">
+            <a:pPr marL="0" indent="0">
               <a:buNone/>
             </a:pPr>
             <a:r>
@@ -8819,7 +8694,7 @@
           <a:bodyPr wrap="square" lIns="0" tIns="0" rIns="0" bIns="0" rtlCol="0" anchor="ctr"/>
           <a:lstStyle/>
           <a:p>
-            <a:pPr algn="ctr" indent="0" marL="0">
+            <a:pPr marL="0" indent="0" algn="ctr">
               <a:buNone/>
             </a:pPr>
             <a:r>
@@ -8855,7 +8730,7 @@
           <a:bodyPr wrap="square" lIns="0" tIns="0" rIns="0" bIns="0" rtlCol="0" anchor="ctr"/>
           <a:lstStyle/>
           <a:p>
-            <a:pPr indent="0" marL="0">
+            <a:pPr marL="0" indent="0">
               <a:buNone/>
             </a:pPr>
             <a:r>
@@ -8891,7 +8766,7 @@
           <a:bodyPr wrap="square" lIns="0" tIns="0" rIns="0" bIns="0" rtlCol="0" anchor="t"/>
           <a:lstStyle/>
           <a:p>
-            <a:pPr indent="0" marL="0">
+            <a:pPr marL="0" indent="0">
               <a:buNone/>
             </a:pPr>
             <a:r>
@@ -8952,7 +8827,7 @@
           <a:bodyPr wrap="square" lIns="0" tIns="0" rIns="0" bIns="0" rtlCol="0" anchor="ctr"/>
           <a:lstStyle/>
           <a:p>
-            <a:pPr algn="ctr" indent="0" marL="0">
+            <a:pPr marL="0" indent="0" algn="ctr">
               <a:buNone/>
             </a:pPr>
             <a:r>
@@ -8988,7 +8863,7 @@
           <a:bodyPr wrap="square" lIns="0" tIns="0" rIns="0" bIns="0" rtlCol="0" anchor="ctr"/>
           <a:lstStyle/>
           <a:p>
-            <a:pPr indent="0" marL="0">
+            <a:pPr marL="0" indent="0">
               <a:buNone/>
             </a:pPr>
             <a:r>
@@ -9024,7 +8899,7 @@
           <a:bodyPr wrap="square" lIns="0" tIns="0" rIns="0" bIns="0" rtlCol="0" anchor="t"/>
           <a:lstStyle/>
           <a:p>
-            <a:pPr indent="0" marL="0">
+            <a:pPr marL="0" indent="0">
               <a:buNone/>
             </a:pPr>
             <a:r>
@@ -9059,7 +8934,7 @@
           </a:prstGeom>
           <a:extLst>
             <a:ext uri="{C572A759-6A51-4108-AA02-DFA0A04FC94B}">
-              <ma14:wrappingTextBoxFlag xmlns:ma14="http://schemas.microsoft.com/office/mac/drawingml/2011/main" val="0"/>
+              <ma14:wrappingTextBoxFlag xmlns="" xmlns:ma14="http://schemas.microsoft.com/office/mac/drawingml/2011/main" val="0"/>
             </a:ext>
           </a:extLst>
         </p:spPr>
@@ -9077,7 +8952,7 @@
           <a:p>
             <a:pPr algn="r"/>
             <a:fld id="{F7021451-1387-4CA6-816F-3879F97B5CBC}" type="slidenum">
-              <a:rPr b="0" lang="en-US"/>
+              <a:rPr lang="en-US" b="0"/>
               <a:t>5</a:t>
             </a:fld>
             <a:endParaRPr lang="en-US"/>
@@ -9130,7 +9005,7 @@
           <a:bodyPr wrap="square" lIns="0" tIns="0" rIns="0" bIns="0" rtlCol="0" anchor="ctr"/>
           <a:lstStyle/>
           <a:p>
-            <a:pPr indent="0" marL="0">
+            <a:pPr marL="0" indent="0">
               <a:buNone/>
             </a:pPr>
             <a:r>
@@ -9175,14 +9050,14 @@
       </p:sp>
       <p:pic>
         <p:nvPicPr>
-          <p:cNvPr id="4" name="Point icon 1 icon" descr="Point icon 1">    </p:cNvPr>
+          <p:cNvPr id="4" name="Point icon 1 icon" descr="Point icon 1"/>
           <p:cNvPicPr>
             <a:picLocks noChangeAspect="1"/>
           </p:cNvPicPr>
           <p:nvPr/>
         </p:nvPicPr>
         <p:blipFill>
-          <a:blip r:embed="rId1"/>
+          <a:blip r:embed="rId3"/>
           <a:stretch>
             <a:fillRect/>
           </a:stretch>
@@ -9218,7 +9093,7 @@
           <a:bodyPr wrap="square" lIns="0" tIns="0" rIns="0" bIns="0" rtlCol="0" anchor="ctr"/>
           <a:lstStyle/>
           <a:p>
-            <a:pPr indent="0" marL="0">
+            <a:pPr marL="0" indent="0">
               <a:buNone/>
             </a:pPr>
             <a:r>
@@ -9254,7 +9129,7 @@
           <a:bodyPr wrap="square" lIns="0" tIns="0" rIns="0" bIns="0" rtlCol="0" anchor="t"/>
           <a:lstStyle/>
           <a:p>
-            <a:pPr indent="0" marL="0">
+            <a:pPr marL="0" indent="0">
               <a:buNone/>
             </a:pPr>
             <a:r>
@@ -9296,14 +9171,14 @@
       </p:sp>
       <p:pic>
         <p:nvPicPr>
-          <p:cNvPr id="8" name="Point icon 2 icon" descr="Point icon 2">    </p:cNvPr>
+          <p:cNvPr id="8" name="Point icon 2 icon" descr="Point icon 2"/>
           <p:cNvPicPr>
             <a:picLocks noChangeAspect="1"/>
           </p:cNvPicPr>
           <p:nvPr/>
         </p:nvPicPr>
         <p:blipFill>
-          <a:blip r:embed="rId2"/>
+          <a:blip r:embed="rId4"/>
           <a:stretch>
             <a:fillRect/>
           </a:stretch>
@@ -9339,7 +9214,7 @@
           <a:bodyPr wrap="square" lIns="0" tIns="0" rIns="0" bIns="0" rtlCol="0" anchor="ctr"/>
           <a:lstStyle/>
           <a:p>
-            <a:pPr indent="0" marL="0">
+            <a:pPr marL="0" indent="0">
               <a:buNone/>
             </a:pPr>
             <a:r>
@@ -9375,7 +9250,7 @@
           <a:bodyPr wrap="square" lIns="0" tIns="0" rIns="0" bIns="0" rtlCol="0" anchor="t"/>
           <a:lstStyle/>
           <a:p>
-            <a:pPr indent="0" marL="0">
+            <a:pPr marL="0" indent="0">
               <a:buNone/>
             </a:pPr>
             <a:r>
@@ -9417,14 +9292,14 @@
       </p:sp>
       <p:pic>
         <p:nvPicPr>
-          <p:cNvPr id="12" name="Point icon 3 icon" descr="Point icon 3">    </p:cNvPr>
+          <p:cNvPr id="12" name="Point icon 3 icon" descr="Point icon 3"/>
           <p:cNvPicPr>
             <a:picLocks noChangeAspect="1"/>
           </p:cNvPicPr>
           <p:nvPr/>
         </p:nvPicPr>
         <p:blipFill>
-          <a:blip r:embed="rId3"/>
+          <a:blip r:embed="rId5"/>
           <a:stretch>
             <a:fillRect/>
           </a:stretch>
@@ -9460,7 +9335,7 @@
           <a:bodyPr wrap="square" lIns="0" tIns="0" rIns="0" bIns="0" rtlCol="0" anchor="ctr"/>
           <a:lstStyle/>
           <a:p>
-            <a:pPr indent="0" marL="0">
+            <a:pPr marL="0" indent="0">
               <a:buNone/>
             </a:pPr>
             <a:r>
@@ -9496,7 +9371,7 @@
           <a:bodyPr wrap="square" lIns="0" tIns="0" rIns="0" bIns="0" rtlCol="0" anchor="t"/>
           <a:lstStyle/>
           <a:p>
-            <a:pPr indent="0" marL="0">
+            <a:pPr marL="0" indent="0">
               <a:buNone/>
             </a:pPr>
             <a:r>
@@ -9540,14 +9415,14 @@
       </p:sp>
       <p:pic>
         <p:nvPicPr>
-          <p:cNvPr id="16" name="AI flow diagram" descr="Sequence: browser, FastAPI, Google certificates, Groq">    </p:cNvPr>
+          <p:cNvPr id="16" name="AI flow diagram" descr="Sequence: browser, FastAPI, Google certificates, Groq"/>
           <p:cNvPicPr>
             <a:picLocks noChangeAspect="1"/>
           </p:cNvPicPr>
           <p:nvPr/>
         </p:nvPicPr>
         <p:blipFill>
-          <a:blip r:embed="rId4"/>
+          <a:blip r:embed="rId6"/>
           <a:stretch>
             <a:fillRect/>
           </a:stretch>
@@ -9582,7 +9457,7 @@
           </a:prstGeom>
           <a:extLst>
             <a:ext uri="{C572A759-6A51-4108-AA02-DFA0A04FC94B}">
-              <ma14:wrappingTextBoxFlag xmlns:ma14="http://schemas.microsoft.com/office/mac/drawingml/2011/main" val="0"/>
+              <ma14:wrappingTextBoxFlag xmlns="" xmlns:ma14="http://schemas.microsoft.com/office/mac/drawingml/2011/main" val="0"/>
             </a:ext>
           </a:extLst>
         </p:spPr>
@@ -9600,7 +9475,7 @@
           <a:p>
             <a:pPr algn="r"/>
             <a:fld id="{F7021451-1387-4CA6-816F-3879F97B5CBC}" type="slidenum">
-              <a:rPr b="0" lang="en-US"/>
+              <a:rPr lang="en-US" b="0"/>
               <a:t>6</a:t>
             </a:fld>
             <a:endParaRPr lang="en-US"/>
@@ -9653,7 +9528,7 @@
           <a:bodyPr wrap="square" lIns="0" tIns="0" rIns="0" bIns="0" rtlCol="0" anchor="ctr"/>
           <a:lstStyle/>
           <a:p>
-            <a:pPr indent="0" marL="0">
+            <a:pPr marL="0" indent="0">
               <a:buNone/>
             </a:pPr>
             <a:r>
@@ -9725,14 +9600,14 @@
       </p:sp>
       <p:pic>
         <p:nvPicPr>
-          <p:cNvPr id="5" name="Tech icon 1 icon" descr="Tech icon 1">    </p:cNvPr>
+          <p:cNvPr id="5" name="Tech icon 1 icon" descr="Tech icon 1"/>
           <p:cNvPicPr>
             <a:picLocks noChangeAspect="1"/>
           </p:cNvPicPr>
           <p:nvPr/>
         </p:nvPicPr>
         <p:blipFill>
-          <a:blip r:embed="rId1"/>
+          <a:blip r:embed="rId3"/>
           <a:stretch>
             <a:fillRect/>
           </a:stretch>
@@ -9768,7 +9643,7 @@
           <a:bodyPr wrap="square" lIns="0" tIns="0" rIns="0" bIns="0" rtlCol="0" anchor="ctr"/>
           <a:lstStyle/>
           <a:p>
-            <a:pPr indent="0" marL="0">
+            <a:pPr marL="0" indent="0">
               <a:buNone/>
             </a:pPr>
             <a:r>
@@ -9931,14 +9806,14 @@
       </p:sp>
       <p:pic>
         <p:nvPicPr>
-          <p:cNvPr id="10" name="Tech icon 2 icon" descr="Tech icon 2">    </p:cNvPr>
+          <p:cNvPr id="10" name="Tech icon 2 icon" descr="Tech icon 2"/>
           <p:cNvPicPr>
             <a:picLocks noChangeAspect="1"/>
           </p:cNvPicPr>
           <p:nvPr/>
         </p:nvPicPr>
         <p:blipFill>
-          <a:blip r:embed="rId2"/>
+          <a:blip r:embed="rId4"/>
           <a:stretch>
             <a:fillRect/>
           </a:stretch>
@@ -9974,7 +9849,7 @@
           <a:bodyPr wrap="square" lIns="0" tIns="0" rIns="0" bIns="0" rtlCol="0" anchor="ctr"/>
           <a:lstStyle/>
           <a:p>
-            <a:pPr indent="0" marL="0">
+            <a:pPr marL="0" indent="0">
               <a:buNone/>
             </a:pPr>
             <a:r>
@@ -10137,14 +10012,14 @@
       </p:sp>
       <p:pic>
         <p:nvPicPr>
-          <p:cNvPr id="15" name="Tech icon 3 icon" descr="Tech icon 3">    </p:cNvPr>
+          <p:cNvPr id="15" name="Tech icon 3 icon" descr="Tech icon 3"/>
           <p:cNvPicPr>
             <a:picLocks noChangeAspect="1"/>
           </p:cNvPicPr>
           <p:nvPr/>
         </p:nvPicPr>
         <p:blipFill>
-          <a:blip r:embed="rId3"/>
+          <a:blip r:embed="rId5"/>
           <a:stretch>
             <a:fillRect/>
           </a:stretch>
@@ -10180,7 +10055,7 @@
           <a:bodyPr wrap="square" lIns="0" tIns="0" rIns="0" bIns="0" rtlCol="0" anchor="ctr"/>
           <a:lstStyle/>
           <a:p>
-            <a:pPr indent="0" marL="0">
+            <a:pPr marL="0" indent="0">
               <a:buNone/>
             </a:pPr>
             <a:r>
@@ -10343,14 +10218,14 @@
       </p:sp>
       <p:pic>
         <p:nvPicPr>
-          <p:cNvPr id="20" name="Tech icon 4 icon" descr="Tech icon 4">    </p:cNvPr>
+          <p:cNvPr id="20" name="Tech icon 4 icon" descr="Tech icon 4"/>
           <p:cNvPicPr>
             <a:picLocks noChangeAspect="1"/>
           </p:cNvPicPr>
           <p:nvPr/>
         </p:nvPicPr>
         <p:blipFill>
-          <a:blip r:embed="rId4"/>
+          <a:blip r:embed="rId6"/>
           <a:stretch>
             <a:fillRect/>
           </a:stretch>
@@ -10386,7 +10261,7 @@
           <a:bodyPr wrap="square" lIns="0" tIns="0" rIns="0" bIns="0" rtlCol="0" anchor="ctr"/>
           <a:lstStyle/>
           <a:p>
-            <a:pPr indent="0" marL="0">
+            <a:pPr marL="0" indent="0">
               <a:buNone/>
             </a:pPr>
             <a:r>
@@ -10448,12 +10323,12 @@
               <a:buChar char="•"/>
             </a:pPr>
             <a:r>
-              <a:rPr lang="en-US" sz="1300" dirty="0">
-                <a:solidFill>
-                  <a:schemeClr val="tx1"/>
-                </a:solidFill>
-              </a:rPr>
-              <a:t>llama-3.3-70b</a:t>
+              <a:rPr lang="en-US" sz="1300" dirty="0" err="1" smtClean="0"/>
+              <a:t>Openai</a:t>
+            </a:r>
+            <a:r>
+              <a:rPr lang="en-US" sz="1300" dirty="0" smtClean="0"/>
+              <a:t>/gpt-oss-20b</a:t>
             </a:r>
             <a:endParaRPr lang="en-US" sz="1300" dirty="0"/>
           </a:p>
@@ -10515,7 +10390,7 @@
           </a:prstGeom>
           <a:extLst>
             <a:ext uri="{C572A759-6A51-4108-AA02-DFA0A04FC94B}">
-              <ma14:wrappingTextBoxFlag xmlns:ma14="http://schemas.microsoft.com/office/mac/drawingml/2011/main" val="0"/>
+              <ma14:wrappingTextBoxFlag xmlns="" xmlns:ma14="http://schemas.microsoft.com/office/mac/drawingml/2011/main" val="0"/>
             </a:ext>
           </a:extLst>
         </p:spPr>
@@ -10533,7 +10408,7 @@
           <a:p>
             <a:pPr algn="r"/>
             <a:fld id="{F7021451-1387-4CA6-816F-3879F97B5CBC}" type="slidenum">
-              <a:rPr b="0" lang="en-US"/>
+              <a:rPr lang="en-US" b="0"/>
               <a:t>7</a:t>
             </a:fld>
             <a:endParaRPr lang="en-US"/>
@@ -10586,7 +10461,7 @@
           <a:bodyPr wrap="square" lIns="0" tIns="0" rIns="0" bIns="0" rtlCol="0" anchor="ctr"/>
           <a:lstStyle/>
           <a:p>
-            <a:pPr indent="0" marL="0">
+            <a:pPr marL="0" indent="0">
               <a:buNone/>
             </a:pPr>
             <a:r>
@@ -10633,14 +10508,14 @@
       </p:sp>
       <p:pic>
         <p:nvPicPr>
-          <p:cNvPr id="4" name="Data model diagram" descr="Firestore data model under users/{uid}">    </p:cNvPr>
+          <p:cNvPr id="4" name="Data model diagram" descr="Firestore data model under users/{uid}"/>
           <p:cNvPicPr>
             <a:picLocks noChangeAspect="1"/>
           </p:cNvPicPr>
           <p:nvPr/>
         </p:nvPicPr>
         <p:blipFill>
-          <a:blip r:embed="rId1"/>
+          <a:blip r:embed="rId3"/>
           <a:stretch>
             <a:fillRect/>
           </a:stretch>
@@ -10676,7 +10551,7 @@
           <a:bodyPr wrap="square" lIns="0" tIns="0" rIns="0" bIns="0" rtlCol="0" anchor="ctr"/>
           <a:lstStyle/>
           <a:p>
-            <a:pPr indent="0" marL="0">
+            <a:pPr marL="0" indent="0">
               <a:buNone/>
             </a:pPr>
             <a:r>
@@ -10690,7 +10565,7 @@
             <a:endParaRPr lang="en-US" sz="1400" dirty="0"/>
           </a:p>
           <a:p>
-            <a:pPr indent="0" marL="0">
+            <a:pPr marL="0" indent="0">
               <a:buNone/>
             </a:pPr>
             <a:r>
@@ -10753,7 +10628,7 @@
           <a:bodyPr wrap="square" lIns="0" tIns="0" rIns="0" bIns="0" rtlCol="0" anchor="t"/>
           <a:lstStyle/>
           <a:p>
-            <a:pPr indent="0" marL="0">
+            <a:pPr marL="0" indent="0">
               <a:buNone/>
             </a:pPr>
             <a:r>
@@ -10770,7 +10645,7 @@
             <a:endParaRPr lang="en-US" sz="1250" dirty="0"/>
           </a:p>
           <a:p>
-            <a:pPr indent="0" marL="0">
+            <a:pPr marL="0" indent="0">
               <a:buNone/>
             </a:pPr>
             <a:r>
@@ -10787,7 +10662,7 @@
             <a:endParaRPr lang="en-US" sz="1250" dirty="0"/>
           </a:p>
           <a:p>
-            <a:pPr indent="0" marL="0">
+            <a:pPr marL="0" indent="0">
               <a:buNone/>
             </a:pPr>
             <a:r>
@@ -10804,7 +10679,7 @@
             <a:endParaRPr lang="en-US" sz="1250" dirty="0"/>
           </a:p>
           <a:p>
-            <a:pPr indent="0" marL="0">
+            <a:pPr marL="0" indent="0">
               <a:buNone/>
             </a:pPr>
             <a:r>
@@ -10821,7 +10696,7 @@
             <a:endParaRPr lang="en-US" sz="1250" dirty="0"/>
           </a:p>
           <a:p>
-            <a:pPr indent="0" marL="0">
+            <a:pPr marL="0" indent="0">
               <a:buNone/>
             </a:pPr>
             <a:r>
@@ -10941,7 +10816,7 @@
           </a:prstGeom>
           <a:extLst>
             <a:ext uri="{C572A759-6A51-4108-AA02-DFA0A04FC94B}">
-              <ma14:wrappingTextBoxFlag xmlns:ma14="http://schemas.microsoft.com/office/mac/drawingml/2011/main" val="0"/>
+              <ma14:wrappingTextBoxFlag xmlns="" xmlns:ma14="http://schemas.microsoft.com/office/mac/drawingml/2011/main" val="0"/>
             </a:ext>
           </a:extLst>
         </p:spPr>
@@ -10959,7 +10834,7 @@
           <a:p>
             <a:pPr algn="r"/>
             <a:fld id="{F7021451-1387-4CA6-816F-3879F97B5CBC}" type="slidenum">
-              <a:rPr b="0" lang="en-US"/>
+              <a:rPr lang="en-US" b="0"/>
               <a:t>8</a:t>
             </a:fld>
             <a:endParaRPr lang="en-US"/>
@@ -11012,7 +10887,7 @@
           <a:bodyPr wrap="square" lIns="0" tIns="0" rIns="0" bIns="0" rtlCol="0" anchor="ctr"/>
           <a:lstStyle/>
           <a:p>
-            <a:pPr indent="0" marL="0">
+            <a:pPr marL="0" indent="0">
               <a:buNone/>
             </a:pPr>
             <a:r>
@@ -11084,14 +10959,14 @@
       </p:sp>
       <p:pic>
         <p:nvPicPr>
-          <p:cNvPr id="5" name="AI icon 1 icon" descr="AI icon 1">    </p:cNvPr>
+          <p:cNvPr id="5" name="AI icon 1 icon" descr="AI icon 1"/>
           <p:cNvPicPr>
             <a:picLocks noChangeAspect="1"/>
           </p:cNvPicPr>
           <p:nvPr/>
         </p:nvPicPr>
         <p:blipFill>
-          <a:blip r:embed="rId1"/>
+          <a:blip r:embed="rId3"/>
           <a:stretch>
             <a:fillRect/>
           </a:stretch>
@@ -11127,7 +11002,7 @@
           <a:bodyPr wrap="square" lIns="0" tIns="0" rIns="0" bIns="0" rtlCol="0" anchor="ctr"/>
           <a:lstStyle/>
           <a:p>
-            <a:pPr indent="0" marL="0">
+            <a:pPr marL="0" indent="0">
               <a:buNone/>
             </a:pPr>
             <a:r>
@@ -11163,7 +11038,7 @@
           <a:bodyPr wrap="square" lIns="0" tIns="0" rIns="0" bIns="0" rtlCol="0" anchor="t"/>
           <a:lstStyle/>
           <a:p>
-            <a:pPr indent="0" marL="0">
+            <a:pPr marL="0" indent="0">
               <a:buNone/>
             </a:pPr>
             <a:r>
@@ -11232,14 +11107,14 @@
       </p:sp>
       <p:pic>
         <p:nvPicPr>
-          <p:cNvPr id="10" name="AI icon 2 icon" descr="AI icon 2">    </p:cNvPr>
+          <p:cNvPr id="10" name="AI icon 2 icon" descr="AI icon 2"/>
           <p:cNvPicPr>
             <a:picLocks noChangeAspect="1"/>
           </p:cNvPicPr>
           <p:nvPr/>
         </p:nvPicPr>
         <p:blipFill>
-          <a:blip r:embed="rId2"/>
+          <a:blip r:embed="rId4"/>
           <a:stretch>
             <a:fillRect/>
           </a:stretch>
@@ -11275,7 +11150,7 @@
           <a:bodyPr wrap="square" lIns="0" tIns="0" rIns="0" bIns="0" rtlCol="0" anchor="ctr"/>
           <a:lstStyle/>
           <a:p>
-            <a:pPr indent="0" marL="0">
+            <a:pPr marL="0" indent="0">
               <a:buNone/>
             </a:pPr>
             <a:r>
@@ -11311,7 +11186,7 @@
           <a:bodyPr wrap="square" lIns="0" tIns="0" rIns="0" bIns="0" rtlCol="0" anchor="t"/>
           <a:lstStyle/>
           <a:p>
-            <a:pPr indent="0" marL="0">
+            <a:pPr marL="0" indent="0">
               <a:buNone/>
             </a:pPr>
             <a:r>
@@ -11380,14 +11255,14 @@
       </p:sp>
       <p:pic>
         <p:nvPicPr>
-          <p:cNvPr id="15" name="AI icon 3 icon" descr="AI icon 3">    </p:cNvPr>
+          <p:cNvPr id="15" name="AI icon 3 icon" descr="AI icon 3"/>
           <p:cNvPicPr>
             <a:picLocks noChangeAspect="1"/>
           </p:cNvPicPr>
           <p:nvPr/>
         </p:nvPicPr>
         <p:blipFill>
-          <a:blip r:embed="rId3"/>
+          <a:blip r:embed="rId5"/>
           <a:stretch>
             <a:fillRect/>
           </a:stretch>
@@ -11423,7 +11298,7 @@
           <a:bodyPr wrap="square" lIns="0" tIns="0" rIns="0" bIns="0" rtlCol="0" anchor="ctr"/>
           <a:lstStyle/>
           <a:p>
-            <a:pPr indent="0" marL="0">
+            <a:pPr marL="0" indent="0">
               <a:buNone/>
             </a:pPr>
             <a:r>
@@ -11459,7 +11334,7 @@
           <a:bodyPr wrap="square" lIns="0" tIns="0" rIns="0" bIns="0" rtlCol="0" anchor="t"/>
           <a:lstStyle/>
           <a:p>
-            <a:pPr indent="0" marL="0">
+            <a:pPr marL="0" indent="0">
               <a:buNone/>
             </a:pPr>
             <a:r>
@@ -11528,14 +11403,14 @@
       </p:sp>
       <p:pic>
         <p:nvPicPr>
-          <p:cNvPr id="20" name="AI icon 4 icon" descr="AI icon 4">    </p:cNvPr>
+          <p:cNvPr id="20" name="AI icon 4 icon" descr="AI icon 4"/>
           <p:cNvPicPr>
             <a:picLocks noChangeAspect="1"/>
           </p:cNvPicPr>
           <p:nvPr/>
         </p:nvPicPr>
         <p:blipFill>
-          <a:blip r:embed="rId4"/>
+          <a:blip r:embed="rId6"/>
           <a:stretch>
             <a:fillRect/>
           </a:stretch>
@@ -11571,7 +11446,7 @@
           <a:bodyPr wrap="square" lIns="0" tIns="0" rIns="0" bIns="0" rtlCol="0" anchor="ctr"/>
           <a:lstStyle/>
           <a:p>
-            <a:pPr indent="0" marL="0">
+            <a:pPr marL="0" indent="0">
               <a:buNone/>
             </a:pPr>
             <a:r>
@@ -11607,7 +11482,7 @@
           <a:bodyPr wrap="square" lIns="0" tIns="0" rIns="0" bIns="0" rtlCol="0" anchor="t"/>
           <a:lstStyle/>
           <a:p>
-            <a:pPr indent="0" marL="0">
+            <a:pPr marL="0" indent="0">
               <a:buNone/>
             </a:pPr>
             <a:r>
@@ -11670,7 +11545,7 @@
           <a:bodyPr wrap="square" lIns="0" tIns="0" rIns="0" bIns="0" rtlCol="0" anchor="ctr"/>
           <a:lstStyle/>
           <a:p>
-            <a:pPr indent="0" marL="0">
+            <a:pPr marL="0" indent="0">
               <a:buNone/>
             </a:pPr>
             <a:r>
@@ -11784,7 +11659,7 @@
       </p:sp>
       <p:sp>
         <p:nvSpPr>
-          <p:cNvPr id="25" name="Slide Number Placeholder 0"/>
+          <p:cNvPr id="26" name="Slide Number Placeholder 0"/>
           <p:cNvSpPr>
             <a:spLocks noGrp="1"/>
           </p:cNvSpPr>
@@ -11802,7 +11677,7 @@
           </a:prstGeom>
           <a:extLst>
             <a:ext uri="{C572A759-6A51-4108-AA02-DFA0A04FC94B}">
-              <ma14:wrappingTextBoxFlag xmlns:ma14="http://schemas.microsoft.com/office/mac/drawingml/2011/main" val="0"/>
+              <ma14:wrappingTextBoxFlag xmlns="" xmlns:ma14="http://schemas.microsoft.com/office/mac/drawingml/2011/main" val="0"/>
             </a:ext>
           </a:extLst>
         </p:spPr>
@@ -11820,7 +11695,7 @@
           <a:p>
             <a:pPr algn="r"/>
             <a:fld id="{F7021451-1387-4CA6-816F-3879F97B5CBC}" type="slidenum">
-              <a:rPr b="0" lang="en-US"/>
+              <a:rPr lang="en-US" b="0"/>
               <a:t>9</a:t>
             </a:fld>
             <a:endParaRPr lang="en-US"/>
@@ -12128,4 +12003,265 @@
     </a:ext>
   </a:extLst>
 </a:theme>
+</file>
+
+<file path=ppt/theme/theme2.xml><?xml version="1.0" encoding="utf-8"?>
+<a:theme xmlns:a="http://schemas.openxmlformats.org/drawingml/2006/main" name="Office Theme">
+  <a:themeElements>
+    <a:clrScheme name="Office">
+      <a:dk1>
+        <a:sysClr val="windowText" lastClr="000000"/>
+      </a:dk1>
+      <a:lt1>
+        <a:sysClr val="window" lastClr="FFFFFF"/>
+      </a:lt1>
+      <a:dk2>
+        <a:srgbClr val="44546A"/>
+      </a:dk2>
+      <a:lt2>
+        <a:srgbClr val="E7E6E6"/>
+      </a:lt2>
+      <a:accent1>
+        <a:srgbClr val="5B9BD5"/>
+      </a:accent1>
+      <a:accent2>
+        <a:srgbClr val="ED7D31"/>
+      </a:accent2>
+      <a:accent3>
+        <a:srgbClr val="A5A5A5"/>
+      </a:accent3>
+      <a:accent4>
+        <a:srgbClr val="FFC000"/>
+      </a:accent4>
+      <a:accent5>
+        <a:srgbClr val="4472C4"/>
+      </a:accent5>
+      <a:accent6>
+        <a:srgbClr val="70AD47"/>
+      </a:accent6>
+      <a:hlink>
+        <a:srgbClr val="0563C1"/>
+      </a:hlink>
+      <a:folHlink>
+        <a:srgbClr val="954F72"/>
+      </a:folHlink>
+    </a:clrScheme>
+    <a:fontScheme name="Office">
+      <a:majorFont>
+        <a:latin typeface="Calibri Light" panose="020F0302020204030204"/>
+        <a:ea typeface=""/>
+        <a:cs typeface=""/>
+        <a:font script="Jpan" typeface="游ゴシック Light"/>
+        <a:font script="Hang" typeface="맑은 고딕"/>
+        <a:font script="Hans" typeface="等线 Light"/>
+        <a:font script="Hant" typeface="新細明體"/>
+        <a:font script="Arab" typeface="Times New Roman"/>
+        <a:font script="Hebr" typeface="Times New Roman"/>
+        <a:font script="Thai" typeface="Angsana New"/>
+        <a:font script="Ethi" typeface="Nyala"/>
+        <a:font script="Beng" typeface="Vrinda"/>
+        <a:font script="Gujr" typeface="Shruti"/>
+        <a:font script="Khmr" typeface="MoolBoran"/>
+        <a:font script="Knda" typeface="Tunga"/>
+        <a:font script="Guru" typeface="Raavi"/>
+        <a:font script="Cans" typeface="Euphemia"/>
+        <a:font script="Cher" typeface="Plantagenet Cherokee"/>
+        <a:font script="Yiii" typeface="Microsoft Yi Baiti"/>
+        <a:font script="Tibt" typeface="Microsoft Himalaya"/>
+        <a:font script="Thaa" typeface="MV Boli"/>
+        <a:font script="Deva" typeface="Mangal"/>
+        <a:font script="Telu" typeface="Gautami"/>
+        <a:font script="Taml" typeface="Latha"/>
+        <a:font script="Syrc" typeface="Estrangelo Edessa"/>
+        <a:font script="Orya" typeface="Kalinga"/>
+        <a:font script="Mlym" typeface="Kartika"/>
+        <a:font script="Laoo" typeface="DokChampa"/>
+        <a:font script="Sinh" typeface="Iskoola Pota"/>
+        <a:font script="Mong" typeface="Mongolian Baiti"/>
+        <a:font script="Viet" typeface="Times New Roman"/>
+        <a:font script="Uigh" typeface="Microsoft Uighur"/>
+        <a:font script="Geor" typeface="Sylfaen"/>
+      </a:majorFont>
+      <a:minorFont>
+        <a:latin typeface="Calibri" panose="020F0502020204030204"/>
+        <a:ea typeface=""/>
+        <a:cs typeface=""/>
+        <a:font script="Jpan" typeface="游ゴシック"/>
+        <a:font script="Hang" typeface="맑은 고딕"/>
+        <a:font script="Hans" typeface="等线"/>
+        <a:font script="Hant" typeface="新細明體"/>
+        <a:font script="Arab" typeface="Arial"/>
+        <a:font script="Hebr" typeface="Arial"/>
+        <a:font script="Thai" typeface="Cordia New"/>
+        <a:font script="Ethi" typeface="Nyala"/>
+        <a:font script="Beng" typeface="Vrinda"/>
+        <a:font script="Gujr" typeface="Shruti"/>
+        <a:font script="Khmr" typeface="DaunPenh"/>
+        <a:font script="Knda" typeface="Tunga"/>
+        <a:font script="Guru" typeface="Raavi"/>
+        <a:font script="Cans" typeface="Euphemia"/>
+        <a:font script="Cher" typeface="Plantagenet Cherokee"/>
+        <a:font script="Yiii" typeface="Microsoft Yi Baiti"/>
+        <a:font script="Tibt" typeface="Microsoft Himalaya"/>
+        <a:font script="Thaa" typeface="MV Boli"/>
+        <a:font script="Deva" typeface="Mangal"/>
+        <a:font script="Telu" typeface="Gautami"/>
+        <a:font script="Taml" typeface="Latha"/>
+        <a:font script="Syrc" typeface="Estrangelo Edessa"/>
+        <a:font script="Orya" typeface="Kalinga"/>
+        <a:font script="Mlym" typeface="Kartika"/>
+        <a:font script="Laoo" typeface="DokChampa"/>
+        <a:font script="Sinh" typeface="Iskoola Pota"/>
+        <a:font script="Mong" typeface="Mongolian Baiti"/>
+        <a:font script="Viet" typeface="Arial"/>
+        <a:font script="Uigh" typeface="Microsoft Uighur"/>
+        <a:font script="Geor" typeface="Sylfaen"/>
+      </a:minorFont>
+    </a:fontScheme>
+    <a:fmtScheme name="Office">
+      <a:fillStyleLst>
+        <a:solidFill>
+          <a:schemeClr val="phClr"/>
+        </a:solidFill>
+        <a:gradFill rotWithShape="1">
+          <a:gsLst>
+            <a:gs pos="0">
+              <a:schemeClr val="phClr">
+                <a:lumMod val="110000"/>
+                <a:satMod val="105000"/>
+                <a:tint val="67000"/>
+              </a:schemeClr>
+            </a:gs>
+            <a:gs pos="50000">
+              <a:schemeClr val="phClr">
+                <a:lumMod val="105000"/>
+                <a:satMod val="103000"/>
+                <a:tint val="73000"/>
+              </a:schemeClr>
+            </a:gs>
+            <a:gs pos="100000">
+              <a:schemeClr val="phClr">
+                <a:lumMod val="105000"/>
+                <a:satMod val="109000"/>
+                <a:tint val="81000"/>
+              </a:schemeClr>
+            </a:gs>
+          </a:gsLst>
+          <a:lin ang="5400000" scaled="0"/>
+        </a:gradFill>
+        <a:gradFill rotWithShape="1">
+          <a:gsLst>
+            <a:gs pos="0">
+              <a:schemeClr val="phClr">
+                <a:satMod val="103000"/>
+                <a:lumMod val="102000"/>
+                <a:tint val="94000"/>
+              </a:schemeClr>
+            </a:gs>
+            <a:gs pos="50000">
+              <a:schemeClr val="phClr">
+                <a:satMod val="110000"/>
+                <a:lumMod val="100000"/>
+                <a:shade val="100000"/>
+              </a:schemeClr>
+            </a:gs>
+            <a:gs pos="100000">
+              <a:schemeClr val="phClr">
+                <a:lumMod val="99000"/>
+                <a:satMod val="120000"/>
+                <a:shade val="78000"/>
+              </a:schemeClr>
+            </a:gs>
+          </a:gsLst>
+          <a:lin ang="5400000" scaled="0"/>
+        </a:gradFill>
+      </a:fillStyleLst>
+      <a:lnStyleLst>
+        <a:ln w="6350" cap="flat" cmpd="sng" algn="ctr">
+          <a:solidFill>
+            <a:schemeClr val="phClr"/>
+          </a:solidFill>
+          <a:prstDash val="solid"/>
+          <a:miter lim="800000"/>
+        </a:ln>
+        <a:ln w="12700" cap="flat" cmpd="sng" algn="ctr">
+          <a:solidFill>
+            <a:schemeClr val="phClr"/>
+          </a:solidFill>
+          <a:prstDash val="solid"/>
+          <a:miter lim="800000"/>
+        </a:ln>
+        <a:ln w="19050" cap="flat" cmpd="sng" algn="ctr">
+          <a:solidFill>
+            <a:schemeClr val="phClr"/>
+          </a:solidFill>
+          <a:prstDash val="solid"/>
+          <a:miter lim="800000"/>
+        </a:ln>
+      </a:lnStyleLst>
+      <a:effectStyleLst>
+        <a:effectStyle>
+          <a:effectLst/>
+        </a:effectStyle>
+        <a:effectStyle>
+          <a:effectLst/>
+        </a:effectStyle>
+        <a:effectStyle>
+          <a:effectLst>
+            <a:outerShdw blurRad="57150" dist="19050" dir="5400000" algn="ctr" rotWithShape="0">
+              <a:srgbClr val="000000">
+                <a:alpha val="63000"/>
+              </a:srgbClr>
+            </a:outerShdw>
+          </a:effectLst>
+        </a:effectStyle>
+      </a:effectStyleLst>
+      <a:bgFillStyleLst>
+        <a:solidFill>
+          <a:schemeClr val="phClr"/>
+        </a:solidFill>
+        <a:solidFill>
+          <a:schemeClr val="phClr">
+            <a:tint val="95000"/>
+            <a:satMod val="170000"/>
+          </a:schemeClr>
+        </a:solidFill>
+        <a:gradFill rotWithShape="1">
+          <a:gsLst>
+            <a:gs pos="0">
+              <a:schemeClr val="phClr">
+                <a:tint val="93000"/>
+                <a:satMod val="150000"/>
+                <a:shade val="98000"/>
+                <a:lumMod val="102000"/>
+              </a:schemeClr>
+            </a:gs>
+            <a:gs pos="50000">
+              <a:schemeClr val="phClr">
+                <a:tint val="98000"/>
+                <a:satMod val="130000"/>
+                <a:shade val="90000"/>
+                <a:lumMod val="103000"/>
+              </a:schemeClr>
+            </a:gs>
+            <a:gs pos="100000">
+              <a:schemeClr val="phClr">
+                <a:shade val="63000"/>
+                <a:satMod val="120000"/>
+              </a:schemeClr>
+            </a:gs>
+          </a:gsLst>
+          <a:lin ang="5400000" scaled="0"/>
+        </a:gradFill>
+      </a:bgFillStyleLst>
+    </a:fmtScheme>
+  </a:themeElements>
+  <a:objectDefaults/>
+  <a:extraClrSchemeLst/>
+  <a:extLst>
+    <a:ext uri="{05A4C25C-085E-4340-85A3-A5531E510DB2}">
+      <thm15:themeFamily xmlns:thm15="http://schemas.microsoft.com/office/thememl/2012/main" name="Office Theme" id="{62F939B6-93AF-4DB8-9C6B-D6C7DFDC589F}" vid="{4A3C46E8-61CC-4603-A589-7422A47A8E4A}"/>
+    </a:ext>
+  </a:extLst>
+</a:theme>
 </file>
</xml_diff>